<commit_message>
Update AI_Agent_Explainability presentation with new content and revisions
</commit_message>
<xml_diff>
--- a/slides/AI_Agent_Explainability - Copy.pptx
+++ b/slides/AI_Agent_Explainability - Copy.pptx
@@ -5,18 +5,23 @@
     <p:sldMasterId id="2147483648" r:id="rId1"/>
     <p:sldMasterId id="2147483661" r:id="rId2"/>
   </p:sldMasterIdLst>
+  <p:notesMasterIdLst>
+    <p:notesMasterId r:id="rId16"/>
+  </p:notesMasterIdLst>
   <p:sldIdLst>
     <p:sldId id="297" r:id="rId3"/>
     <p:sldId id="298" r:id="rId4"/>
     <p:sldId id="299" r:id="rId5"/>
-    <p:sldId id="301" r:id="rId6"/>
+    <p:sldId id="519" r:id="rId6"/>
     <p:sldId id="300" r:id="rId7"/>
     <p:sldId id="302" r:id="rId8"/>
     <p:sldId id="305" r:id="rId9"/>
     <p:sldId id="306" r:id="rId10"/>
     <p:sldId id="307" r:id="rId11"/>
-    <p:sldId id="303" r:id="rId12"/>
-    <p:sldId id="304" r:id="rId13"/>
+    <p:sldId id="556" r:id="rId12"/>
+    <p:sldId id="303" r:id="rId13"/>
+    <p:sldId id="304" r:id="rId14"/>
+    <p:sldId id="301" r:id="rId15"/>
   </p:sldIdLst>
   <p:sldSz cx="9144000" cy="6858000" type="screen4x3"/>
   <p:notesSz cx="7559675" cy="10691813"/>
@@ -125,45 +130,6 @@
 
 <file path=ppt/changesInfos/changesInfo1.xml><?xml version="1.0" encoding="utf-8"?>
 <pc:chgInfo xmlns:a="http://schemas.openxmlformats.org/drawingml/2006/main" xmlns:r="http://schemas.openxmlformats.org/officeDocument/2006/relationships" xmlns:ac="http://schemas.microsoft.com/office/drawing/2013/main/command" xmlns:pc="http://schemas.microsoft.com/office/powerpoint/2013/main/command">
-  <pc:docChgLst>
-    <pc:chgData name="Tiago Janela" userId="ee1a79fe-c79c-4f34-9602-7f6f2f0482b3" providerId="ADAL" clId="{67D2C233-DF3C-4C6D-9040-D7553E3BCB8A}"/>
-    <pc:docChg chg="delSld modSld">
-      <pc:chgData name="Tiago Janela" userId="ee1a79fe-c79c-4f34-9602-7f6f2f0482b3" providerId="ADAL" clId="{67D2C233-DF3C-4C6D-9040-D7553E3BCB8A}" dt="2026-03-16T14:03:02.466" v="54" actId="20577"/>
-      <pc:docMkLst>
-        <pc:docMk/>
-      </pc:docMkLst>
-      <pc:sldChg chg="modSp mod">
-        <pc:chgData name="Tiago Janela" userId="ee1a79fe-c79c-4f34-9602-7f6f2f0482b3" providerId="ADAL" clId="{67D2C233-DF3C-4C6D-9040-D7553E3BCB8A}" dt="2026-03-16T14:03:02.466" v="54" actId="20577"/>
-        <pc:sldMkLst>
-          <pc:docMk/>
-          <pc:sldMk cId="829672710" sldId="297"/>
-        </pc:sldMkLst>
-        <pc:spChg chg="mod">
-          <ac:chgData name="Tiago Janela" userId="ee1a79fe-c79c-4f34-9602-7f6f2f0482b3" providerId="ADAL" clId="{67D2C233-DF3C-4C6D-9040-D7553E3BCB8A}" dt="2026-03-16T14:03:02.466" v="54" actId="20577"/>
-          <ac:spMkLst>
-            <pc:docMk/>
-            <pc:sldMk cId="829672710" sldId="297"/>
-            <ac:spMk id="156" creationId="{00000000-0000-0000-0000-000000000000}"/>
-          </ac:spMkLst>
-        </pc:spChg>
-      </pc:sldChg>
-      <pc:sldChg chg="modSp mod">
-        <pc:chgData name="Tiago Janela" userId="ee1a79fe-c79c-4f34-9602-7f6f2f0482b3" providerId="ADAL" clId="{67D2C233-DF3C-4C6D-9040-D7553E3BCB8A}" dt="2026-03-16T14:02:34.148" v="0" actId="20577"/>
-        <pc:sldMkLst>
-          <pc:docMk/>
-          <pc:sldMk cId="721732568" sldId="298"/>
-        </pc:sldMkLst>
-        <pc:spChg chg="mod">
-          <ac:chgData name="Tiago Janela" userId="ee1a79fe-c79c-4f34-9602-7f6f2f0482b3" providerId="ADAL" clId="{67D2C233-DF3C-4C6D-9040-D7553E3BCB8A}" dt="2026-03-16T14:02:34.148" v="0" actId="20577"/>
-          <ac:spMkLst>
-            <pc:docMk/>
-            <pc:sldMk cId="721732568" sldId="298"/>
-            <ac:spMk id="2" creationId="{870990D0-7AC5-46BA-6FC4-274F8E0A3ABE}"/>
-          </ac:spMkLst>
-        </pc:spChg>
-      </pc:sldChg>
-    </pc:docChg>
-  </pc:docChgLst>
   <pc:docChgLst>
     <pc:chgData name="Tiago Janela" userId="ee1a79fe-c79c-4f34-9602-7f6f2f0482b3" providerId="ADAL" clId="{6BE67FA1-4A27-48B9-BA6A-E25A9786A9CC}"/>
     <pc:docChg chg="undo custSel addSld modSld sldOrd">
@@ -298,6 +264,90 @@
     </pc:docChg>
   </pc:docChgLst>
   <pc:docChgLst>
+    <pc:chgData name="Tiago Janela" userId="ee1a79fe-c79c-4f34-9602-7f6f2f0482b3" providerId="ADAL" clId="{FF6951D0-D029-4985-BC76-70E5B4A62478}"/>
+    <pc:docChg chg="addSld modSld sldOrd">
+      <pc:chgData name="Tiago Janela" userId="ee1a79fe-c79c-4f34-9602-7f6f2f0482b3" providerId="ADAL" clId="{FF6951D0-D029-4985-BC76-70E5B4A62478}" dt="2026-04-24T09:48:18.185" v="6"/>
+      <pc:docMkLst>
+        <pc:docMk/>
+      </pc:docMkLst>
+      <pc:sldChg chg="modSp mod">
+        <pc:chgData name="Tiago Janela" userId="ee1a79fe-c79c-4f34-9602-7f6f2f0482b3" providerId="ADAL" clId="{FF6951D0-D029-4985-BC76-70E5B4A62478}" dt="2026-04-24T09:45:33.131" v="1" actId="20577"/>
+        <pc:sldMkLst>
+          <pc:docMk/>
+          <pc:sldMk cId="1707478755" sldId="299"/>
+        </pc:sldMkLst>
+        <pc:spChg chg="mod">
+          <ac:chgData name="Tiago Janela" userId="ee1a79fe-c79c-4f34-9602-7f6f2f0482b3" providerId="ADAL" clId="{FF6951D0-D029-4985-BC76-70E5B4A62478}" dt="2026-04-24T09:45:33.131" v="1" actId="20577"/>
+          <ac:spMkLst>
+            <pc:docMk/>
+            <pc:sldMk cId="1707478755" sldId="299"/>
+            <ac:spMk id="2" creationId="{870990D0-7AC5-46BA-6FC4-274F8E0A3ABE}"/>
+          </ac:spMkLst>
+        </pc:spChg>
+      </pc:sldChg>
+      <pc:sldChg chg="mod ord modShow">
+        <pc:chgData name="Tiago Janela" userId="ee1a79fe-c79c-4f34-9602-7f6f2f0482b3" providerId="ADAL" clId="{FF6951D0-D029-4985-BC76-70E5B4A62478}" dt="2026-04-24T09:47:45.785" v="5"/>
+        <pc:sldMkLst>
+          <pc:docMk/>
+          <pc:sldMk cId="2375808848" sldId="301"/>
+        </pc:sldMkLst>
+      </pc:sldChg>
+      <pc:sldChg chg="add">
+        <pc:chgData name="Tiago Janela" userId="ee1a79fe-c79c-4f34-9602-7f6f2f0482b3" providerId="ADAL" clId="{FF6951D0-D029-4985-BC76-70E5B4A62478}" dt="2026-04-24T09:47:35.256" v="2"/>
+        <pc:sldMkLst>
+          <pc:docMk/>
+          <pc:sldMk cId="921095034" sldId="519"/>
+        </pc:sldMkLst>
+      </pc:sldChg>
+      <pc:sldChg chg="add">
+        <pc:chgData name="Tiago Janela" userId="ee1a79fe-c79c-4f34-9602-7f6f2f0482b3" providerId="ADAL" clId="{FF6951D0-D029-4985-BC76-70E5B4A62478}" dt="2026-04-24T09:48:18.185" v="6"/>
+        <pc:sldMkLst>
+          <pc:docMk/>
+          <pc:sldMk cId="2674446027" sldId="556"/>
+        </pc:sldMkLst>
+      </pc:sldChg>
+    </pc:docChg>
+  </pc:docChgLst>
+  <pc:docChgLst>
+    <pc:chgData name="Tiago Janela" userId="ee1a79fe-c79c-4f34-9602-7f6f2f0482b3" providerId="ADAL" clId="{67D2C233-DF3C-4C6D-9040-D7553E3BCB8A}"/>
+    <pc:docChg chg="delSld modSld">
+      <pc:chgData name="Tiago Janela" userId="ee1a79fe-c79c-4f34-9602-7f6f2f0482b3" providerId="ADAL" clId="{67D2C233-DF3C-4C6D-9040-D7553E3BCB8A}" dt="2026-03-16T14:03:02.466" v="54" actId="20577"/>
+      <pc:docMkLst>
+        <pc:docMk/>
+      </pc:docMkLst>
+      <pc:sldChg chg="modSp mod">
+        <pc:chgData name="Tiago Janela" userId="ee1a79fe-c79c-4f34-9602-7f6f2f0482b3" providerId="ADAL" clId="{67D2C233-DF3C-4C6D-9040-D7553E3BCB8A}" dt="2026-03-16T14:03:02.466" v="54" actId="20577"/>
+        <pc:sldMkLst>
+          <pc:docMk/>
+          <pc:sldMk cId="829672710" sldId="297"/>
+        </pc:sldMkLst>
+        <pc:spChg chg="mod">
+          <ac:chgData name="Tiago Janela" userId="ee1a79fe-c79c-4f34-9602-7f6f2f0482b3" providerId="ADAL" clId="{67D2C233-DF3C-4C6D-9040-D7553E3BCB8A}" dt="2026-03-16T14:03:02.466" v="54" actId="20577"/>
+          <ac:spMkLst>
+            <pc:docMk/>
+            <pc:sldMk cId="829672710" sldId="297"/>
+            <ac:spMk id="156" creationId="{00000000-0000-0000-0000-000000000000}"/>
+          </ac:spMkLst>
+        </pc:spChg>
+      </pc:sldChg>
+      <pc:sldChg chg="modSp mod">
+        <pc:chgData name="Tiago Janela" userId="ee1a79fe-c79c-4f34-9602-7f6f2f0482b3" providerId="ADAL" clId="{67D2C233-DF3C-4C6D-9040-D7553E3BCB8A}" dt="2026-03-16T14:02:34.148" v="0" actId="20577"/>
+        <pc:sldMkLst>
+          <pc:docMk/>
+          <pc:sldMk cId="721732568" sldId="298"/>
+        </pc:sldMkLst>
+        <pc:spChg chg="mod">
+          <ac:chgData name="Tiago Janela" userId="ee1a79fe-c79c-4f34-9602-7f6f2f0482b3" providerId="ADAL" clId="{67D2C233-DF3C-4C6D-9040-D7553E3BCB8A}" dt="2026-03-16T14:02:34.148" v="0" actId="20577"/>
+          <ac:spMkLst>
+            <pc:docMk/>
+            <pc:sldMk cId="721732568" sldId="298"/>
+            <ac:spMk id="2" creationId="{870990D0-7AC5-46BA-6FC4-274F8E0A3ABE}"/>
+          </ac:spMkLst>
+        </pc:spChg>
+      </pc:sldChg>
+    </pc:docChg>
+  </pc:docChgLst>
+  <pc:docChgLst>
     <pc:chgData name="Tiago Janela" userId="ee1a79fe-c79c-4f34-9602-7f6f2f0482b3" providerId="ADAL" clId="{97693404-9C1B-400A-95DF-A7B72570E7A0}"/>
     <pc:docChg chg="undo custSel addSld delSld modSld sldOrd">
       <pc:chgData name="Tiago Janela" userId="ee1a79fe-c79c-4f34-9602-7f6f2f0482b3" providerId="ADAL" clId="{97693404-9C1B-400A-95DF-A7B72570E7A0}" dt="2026-03-09T10:33:25.226" v="5259" actId="20577"/>
@@ -322,6 +372,592 @@
     </pc:docChg>
   </pc:docChgLst>
 </pc:chgInfo>
+</file>
+
+<file path=ppt/notesMasters/notesMaster1.xml><?xml version="1.0" encoding="utf-8"?>
+<p:notesMaster xmlns:a="http://schemas.openxmlformats.org/drawingml/2006/main" xmlns:r="http://schemas.openxmlformats.org/officeDocument/2006/relationships" xmlns:p="http://schemas.openxmlformats.org/presentationml/2006/main">
+  <p:cSld>
+    <p:bg>
+      <p:bgRef idx="1001">
+        <a:schemeClr val="bg1"/>
+      </p:bgRef>
+    </p:bg>
+    <p:spTree>
+      <p:nvGrpSpPr>
+        <p:cNvPr id="1" name=""/>
+        <p:cNvGrpSpPr/>
+        <p:nvPr/>
+      </p:nvGrpSpPr>
+      <p:grpSpPr>
+        <a:xfrm>
+          <a:off x="0" y="0"/>
+          <a:ext cx="0" cy="0"/>
+          <a:chOff x="0" y="0"/>
+          <a:chExt cx="0" cy="0"/>
+        </a:xfrm>
+      </p:grpSpPr>
+      <p:sp>
+        <p:nvSpPr>
+          <p:cNvPr id="2" name="Header Placeholder 1"/>
+          <p:cNvSpPr>
+            <a:spLocks noGrp="1"/>
+          </p:cNvSpPr>
+          <p:nvPr>
+            <p:ph type="hdr" sz="quarter"/>
+          </p:nvPr>
+        </p:nvSpPr>
+        <p:spPr>
+          <a:xfrm>
+            <a:off x="0" y="0"/>
+            <a:ext cx="3276600" cy="536575"/>
+          </a:xfrm>
+          <a:prstGeom prst="rect">
+            <a:avLst/>
+          </a:prstGeom>
+        </p:spPr>
+        <p:txBody>
+          <a:bodyPr vert="horz" lIns="91440" tIns="45720" rIns="91440" bIns="45720" rtlCol="0"/>
+          <a:lstStyle>
+            <a:lvl1pPr algn="l">
+              <a:defRPr sz="1200"/>
+            </a:lvl1pPr>
+          </a:lstStyle>
+          <a:p>
+            <a:endParaRPr lang="de-DE"/>
+          </a:p>
+        </p:txBody>
+      </p:sp>
+      <p:sp>
+        <p:nvSpPr>
+          <p:cNvPr id="3" name="Date Placeholder 2"/>
+          <p:cNvSpPr>
+            <a:spLocks noGrp="1"/>
+          </p:cNvSpPr>
+          <p:nvPr>
+            <p:ph type="dt" idx="1"/>
+          </p:nvPr>
+        </p:nvSpPr>
+        <p:spPr>
+          <a:xfrm>
+            <a:off x="4281488" y="0"/>
+            <a:ext cx="3276600" cy="536575"/>
+          </a:xfrm>
+          <a:prstGeom prst="rect">
+            <a:avLst/>
+          </a:prstGeom>
+        </p:spPr>
+        <p:txBody>
+          <a:bodyPr vert="horz" lIns="91440" tIns="45720" rIns="91440" bIns="45720" rtlCol="0"/>
+          <a:lstStyle>
+            <a:lvl1pPr algn="r">
+              <a:defRPr sz="1200"/>
+            </a:lvl1pPr>
+          </a:lstStyle>
+          <a:p>
+            <a:fld id="{8895F6FA-647C-4311-838E-A4FEC80CEF77}" type="datetimeFigureOut">
+              <a:rPr lang="de-DE" smtClean="0"/>
+              <a:t>24.04.2026</a:t>
+            </a:fld>
+            <a:endParaRPr lang="de-DE"/>
+          </a:p>
+        </p:txBody>
+      </p:sp>
+      <p:sp>
+        <p:nvSpPr>
+          <p:cNvPr id="4" name="Slide Image Placeholder 3"/>
+          <p:cNvSpPr>
+            <a:spLocks noGrp="1" noRot="1" noChangeAspect="1"/>
+          </p:cNvSpPr>
+          <p:nvPr>
+            <p:ph type="sldImg" idx="2"/>
+          </p:nvPr>
+        </p:nvSpPr>
+        <p:spPr>
+          <a:xfrm>
+            <a:off x="1374775" y="1336675"/>
+            <a:ext cx="4810125" cy="3608388"/>
+          </a:xfrm>
+          <a:prstGeom prst="rect">
+            <a:avLst/>
+          </a:prstGeom>
+          <a:noFill/>
+          <a:ln w="12700">
+            <a:solidFill>
+              <a:prstClr val="black"/>
+            </a:solidFill>
+          </a:ln>
+        </p:spPr>
+        <p:txBody>
+          <a:bodyPr vert="horz" lIns="91440" tIns="45720" rIns="91440" bIns="45720" rtlCol="0" anchor="ctr"/>
+          <a:lstStyle/>
+          <a:p>
+            <a:endParaRPr lang="de-DE"/>
+          </a:p>
+        </p:txBody>
+      </p:sp>
+      <p:sp>
+        <p:nvSpPr>
+          <p:cNvPr id="5" name="Notes Placeholder 4"/>
+          <p:cNvSpPr>
+            <a:spLocks noGrp="1"/>
+          </p:cNvSpPr>
+          <p:nvPr>
+            <p:ph type="body" sz="quarter" idx="3"/>
+          </p:nvPr>
+        </p:nvSpPr>
+        <p:spPr>
+          <a:xfrm>
+            <a:off x="755650" y="5145088"/>
+            <a:ext cx="6048375" cy="4210050"/>
+          </a:xfrm>
+          <a:prstGeom prst="rect">
+            <a:avLst/>
+          </a:prstGeom>
+        </p:spPr>
+        <p:txBody>
+          <a:bodyPr vert="horz" lIns="91440" tIns="45720" rIns="91440" bIns="45720" rtlCol="0"/>
+          <a:lstStyle/>
+          <a:p>
+            <a:pPr lvl="0"/>
+            <a:r>
+              <a:rPr lang="en-US"/>
+              <a:t>Click to edit Master text styles</a:t>
+            </a:r>
+          </a:p>
+          <a:p>
+            <a:pPr lvl="1"/>
+            <a:r>
+              <a:rPr lang="en-US"/>
+              <a:t>Second level</a:t>
+            </a:r>
+          </a:p>
+          <a:p>
+            <a:pPr lvl="2"/>
+            <a:r>
+              <a:rPr lang="en-US"/>
+              <a:t>Third level</a:t>
+            </a:r>
+          </a:p>
+          <a:p>
+            <a:pPr lvl="3"/>
+            <a:r>
+              <a:rPr lang="en-US"/>
+              <a:t>Fourth level</a:t>
+            </a:r>
+          </a:p>
+          <a:p>
+            <a:pPr lvl="4"/>
+            <a:r>
+              <a:rPr lang="en-US"/>
+              <a:t>Fifth level</a:t>
+            </a:r>
+            <a:endParaRPr lang="de-DE"/>
+          </a:p>
+        </p:txBody>
+      </p:sp>
+      <p:sp>
+        <p:nvSpPr>
+          <p:cNvPr id="6" name="Footer Placeholder 5"/>
+          <p:cNvSpPr>
+            <a:spLocks noGrp="1"/>
+          </p:cNvSpPr>
+          <p:nvPr>
+            <p:ph type="ftr" sz="quarter" idx="4"/>
+          </p:nvPr>
+        </p:nvSpPr>
+        <p:spPr>
+          <a:xfrm>
+            <a:off x="0" y="10155238"/>
+            <a:ext cx="3276600" cy="536575"/>
+          </a:xfrm>
+          <a:prstGeom prst="rect">
+            <a:avLst/>
+          </a:prstGeom>
+        </p:spPr>
+        <p:txBody>
+          <a:bodyPr vert="horz" lIns="91440" tIns="45720" rIns="91440" bIns="45720" rtlCol="0" anchor="b"/>
+          <a:lstStyle>
+            <a:lvl1pPr algn="l">
+              <a:defRPr sz="1200"/>
+            </a:lvl1pPr>
+          </a:lstStyle>
+          <a:p>
+            <a:endParaRPr lang="de-DE"/>
+          </a:p>
+        </p:txBody>
+      </p:sp>
+      <p:sp>
+        <p:nvSpPr>
+          <p:cNvPr id="7" name="Slide Number Placeholder 6"/>
+          <p:cNvSpPr>
+            <a:spLocks noGrp="1"/>
+          </p:cNvSpPr>
+          <p:nvPr>
+            <p:ph type="sldNum" sz="quarter" idx="5"/>
+          </p:nvPr>
+        </p:nvSpPr>
+        <p:spPr>
+          <a:xfrm>
+            <a:off x="4281488" y="10155238"/>
+            <a:ext cx="3276600" cy="536575"/>
+          </a:xfrm>
+          <a:prstGeom prst="rect">
+            <a:avLst/>
+          </a:prstGeom>
+        </p:spPr>
+        <p:txBody>
+          <a:bodyPr vert="horz" lIns="91440" tIns="45720" rIns="91440" bIns="45720" rtlCol="0" anchor="b"/>
+          <a:lstStyle>
+            <a:lvl1pPr algn="r">
+              <a:defRPr sz="1200"/>
+            </a:lvl1pPr>
+          </a:lstStyle>
+          <a:p>
+            <a:fld id="{B1CB59DE-A395-4FE1-AF6E-B266016DC7B6}" type="slidenum">
+              <a:rPr lang="de-DE" smtClean="0"/>
+              <a:t>‹#›</a:t>
+            </a:fld>
+            <a:endParaRPr lang="de-DE"/>
+          </a:p>
+        </p:txBody>
+      </p:sp>
+    </p:spTree>
+    <p:extLst>
+      <p:ext uri="{BB962C8B-B14F-4D97-AF65-F5344CB8AC3E}">
+        <p14:creationId xmlns:p14="http://schemas.microsoft.com/office/powerpoint/2010/main" val="3301869723"/>
+      </p:ext>
+    </p:extLst>
+  </p:cSld>
+  <p:clrMap bg1="lt1" tx1="dk1" bg2="lt2" tx2="dk2" accent1="accent1" accent2="accent2" accent3="accent3" accent4="accent4" accent5="accent5" accent6="accent6" hlink="hlink" folHlink="folHlink"/>
+  <p:notesStyle>
+    <a:lvl1pPr marL="0" algn="l" defTabSz="914400" rtl="0" eaLnBrk="1" latinLnBrk="0" hangingPunct="1">
+      <a:defRPr sz="1200" kern="1200">
+        <a:solidFill>
+          <a:schemeClr val="tx1"/>
+        </a:solidFill>
+        <a:latin typeface="+mn-lt"/>
+        <a:ea typeface="+mn-ea"/>
+        <a:cs typeface="+mn-cs"/>
+      </a:defRPr>
+    </a:lvl1pPr>
+    <a:lvl2pPr marL="457200" algn="l" defTabSz="914400" rtl="0" eaLnBrk="1" latinLnBrk="0" hangingPunct="1">
+      <a:defRPr sz="1200" kern="1200">
+        <a:solidFill>
+          <a:schemeClr val="tx1"/>
+        </a:solidFill>
+        <a:latin typeface="+mn-lt"/>
+        <a:ea typeface="+mn-ea"/>
+        <a:cs typeface="+mn-cs"/>
+      </a:defRPr>
+    </a:lvl2pPr>
+    <a:lvl3pPr marL="914400" algn="l" defTabSz="914400" rtl="0" eaLnBrk="1" latinLnBrk="0" hangingPunct="1">
+      <a:defRPr sz="1200" kern="1200">
+        <a:solidFill>
+          <a:schemeClr val="tx1"/>
+        </a:solidFill>
+        <a:latin typeface="+mn-lt"/>
+        <a:ea typeface="+mn-ea"/>
+        <a:cs typeface="+mn-cs"/>
+      </a:defRPr>
+    </a:lvl3pPr>
+    <a:lvl4pPr marL="1371600" algn="l" defTabSz="914400" rtl="0" eaLnBrk="1" latinLnBrk="0" hangingPunct="1">
+      <a:defRPr sz="1200" kern="1200">
+        <a:solidFill>
+          <a:schemeClr val="tx1"/>
+        </a:solidFill>
+        <a:latin typeface="+mn-lt"/>
+        <a:ea typeface="+mn-ea"/>
+        <a:cs typeface="+mn-cs"/>
+      </a:defRPr>
+    </a:lvl4pPr>
+    <a:lvl5pPr marL="1828800" algn="l" defTabSz="914400" rtl="0" eaLnBrk="1" latinLnBrk="0" hangingPunct="1">
+      <a:defRPr sz="1200" kern="1200">
+        <a:solidFill>
+          <a:schemeClr val="tx1"/>
+        </a:solidFill>
+        <a:latin typeface="+mn-lt"/>
+        <a:ea typeface="+mn-ea"/>
+        <a:cs typeface="+mn-cs"/>
+      </a:defRPr>
+    </a:lvl5pPr>
+    <a:lvl6pPr marL="2286000" algn="l" defTabSz="914400" rtl="0" eaLnBrk="1" latinLnBrk="0" hangingPunct="1">
+      <a:defRPr sz="1200" kern="1200">
+        <a:solidFill>
+          <a:schemeClr val="tx1"/>
+        </a:solidFill>
+        <a:latin typeface="+mn-lt"/>
+        <a:ea typeface="+mn-ea"/>
+        <a:cs typeface="+mn-cs"/>
+      </a:defRPr>
+    </a:lvl6pPr>
+    <a:lvl7pPr marL="2743200" algn="l" defTabSz="914400" rtl="0" eaLnBrk="1" latinLnBrk="0" hangingPunct="1">
+      <a:defRPr sz="1200" kern="1200">
+        <a:solidFill>
+          <a:schemeClr val="tx1"/>
+        </a:solidFill>
+        <a:latin typeface="+mn-lt"/>
+        <a:ea typeface="+mn-ea"/>
+        <a:cs typeface="+mn-cs"/>
+      </a:defRPr>
+    </a:lvl7pPr>
+    <a:lvl8pPr marL="3200400" algn="l" defTabSz="914400" rtl="0" eaLnBrk="1" latinLnBrk="0" hangingPunct="1">
+      <a:defRPr sz="1200" kern="1200">
+        <a:solidFill>
+          <a:schemeClr val="tx1"/>
+        </a:solidFill>
+        <a:latin typeface="+mn-lt"/>
+        <a:ea typeface="+mn-ea"/>
+        <a:cs typeface="+mn-cs"/>
+      </a:defRPr>
+    </a:lvl8pPr>
+    <a:lvl9pPr marL="3657600" algn="l" defTabSz="914400" rtl="0" eaLnBrk="1" latinLnBrk="0" hangingPunct="1">
+      <a:defRPr sz="1200" kern="1200">
+        <a:solidFill>
+          <a:schemeClr val="tx1"/>
+        </a:solidFill>
+        <a:latin typeface="+mn-lt"/>
+        <a:ea typeface="+mn-ea"/>
+        <a:cs typeface="+mn-cs"/>
+      </a:defRPr>
+    </a:lvl9pPr>
+  </p:notesStyle>
+</p:notesMaster>
+</file>
+
+<file path=ppt/notesSlides/notesSlide1.xml><?xml version="1.0" encoding="utf-8"?>
+<p:notes xmlns:a="http://schemas.openxmlformats.org/drawingml/2006/main" xmlns:r="http://schemas.openxmlformats.org/officeDocument/2006/relationships" xmlns:p="http://schemas.openxmlformats.org/presentationml/2006/main">
+  <p:cSld>
+    <p:spTree>
+      <p:nvGrpSpPr>
+        <p:cNvPr id="1" name=""/>
+        <p:cNvGrpSpPr/>
+        <p:nvPr/>
+      </p:nvGrpSpPr>
+      <p:grpSpPr>
+        <a:xfrm>
+          <a:off x="0" y="0"/>
+          <a:ext cx="0" cy="0"/>
+          <a:chOff x="0" y="0"/>
+          <a:chExt cx="0" cy="0"/>
+        </a:xfrm>
+      </p:grpSpPr>
+      <p:sp>
+        <p:nvSpPr>
+          <p:cNvPr id="2" name="Marcador de Posição da Imagem do Diapositivo 1"/>
+          <p:cNvSpPr>
+            <a:spLocks noGrp="1" noRot="1" noChangeAspect="1"/>
+          </p:cNvSpPr>
+          <p:nvPr>
+            <p:ph type="sldImg"/>
+          </p:nvPr>
+        </p:nvSpPr>
+        <p:spPr/>
+      </p:sp>
+      <p:sp>
+        <p:nvSpPr>
+          <p:cNvPr id="3" name="Marcador de Posição de Notas 2"/>
+          <p:cNvSpPr>
+            <a:spLocks noGrp="1"/>
+          </p:cNvSpPr>
+          <p:nvPr>
+            <p:ph type="body" idx="1"/>
+          </p:nvPr>
+        </p:nvSpPr>
+        <p:spPr/>
+        <p:txBody>
+          <a:bodyPr/>
+          <a:lstStyle/>
+          <a:p>
+            <a:r>
+              <a:rPr lang="en-US" dirty="0"/>
+              <a:t>Here's a concrete example. </a:t>
+            </a:r>
+          </a:p>
+          <a:p>
+            <a:endParaRPr lang="en-US" dirty="0"/>
+          </a:p>
+          <a:p>
+            <a:r>
+              <a:rPr lang="en-US" dirty="0"/>
+              <a:t>The user asks the system to take a kinase selectivity dataset, split it using scaffold partitioning, train a random forest with cross-validated hyperparameter optimization, and report performance. </a:t>
+            </a:r>
+          </a:p>
+          <a:p>
+            <a:endParaRPr lang="en-US" dirty="0"/>
+          </a:p>
+          <a:p>
+            <a:r>
+              <a:rPr lang="en-US" dirty="0"/>
+              <a:t>The agent handles all of this autonomously. This workflow would normally require writing and debugging a Python script — here it's done through a text prompt.</a:t>
+            </a:r>
+            <a:endParaRPr lang="pt-PT" dirty="0"/>
+          </a:p>
+        </p:txBody>
+      </p:sp>
+      <p:sp>
+        <p:nvSpPr>
+          <p:cNvPr id="4" name="Marcador de Posição do Número do Diapositivo 3"/>
+          <p:cNvSpPr>
+            <a:spLocks noGrp="1"/>
+          </p:cNvSpPr>
+          <p:nvPr>
+            <p:ph type="sldNum" sz="quarter" idx="5"/>
+          </p:nvPr>
+        </p:nvSpPr>
+        <p:spPr/>
+        <p:txBody>
+          <a:bodyPr/>
+          <a:lstStyle/>
+          <a:p>
+            <a:fld id="{A8F1D436-8E8C-482D-8D71-F0E649122FF1}" type="slidenum">
+              <a:rPr lang="de-DE" smtClean="0"/>
+              <a:t>4</a:t>
+            </a:fld>
+            <a:endParaRPr lang="de-DE"/>
+          </a:p>
+        </p:txBody>
+      </p:sp>
+    </p:spTree>
+    <p:extLst>
+      <p:ext uri="{BB962C8B-B14F-4D97-AF65-F5344CB8AC3E}">
+        <p14:creationId xmlns:p14="http://schemas.microsoft.com/office/powerpoint/2010/main" val="2609654911"/>
+      </p:ext>
+    </p:extLst>
+  </p:cSld>
+  <p:clrMapOvr>
+    <a:masterClrMapping/>
+  </p:clrMapOvr>
+</p:notes>
+</file>
+
+<file path=ppt/notesSlides/notesSlide2.xml><?xml version="1.0" encoding="utf-8"?>
+<p:notes xmlns:a="http://schemas.openxmlformats.org/drawingml/2006/main" xmlns:r="http://schemas.openxmlformats.org/officeDocument/2006/relationships" xmlns:p="http://schemas.openxmlformats.org/presentationml/2006/main">
+  <p:cSld>
+    <p:spTree>
+      <p:nvGrpSpPr>
+        <p:cNvPr id="1" name="">
+          <a:extLst>
+            <a:ext uri="{FF2B5EF4-FFF2-40B4-BE49-F238E27FC236}">
+              <a16:creationId xmlns:a16="http://schemas.microsoft.com/office/drawing/2014/main" id="{3545D11D-EA46-9A83-3E55-EA32102FD929}"/>
+            </a:ext>
+          </a:extLst>
+        </p:cNvPr>
+        <p:cNvGrpSpPr/>
+        <p:nvPr/>
+      </p:nvGrpSpPr>
+      <p:grpSpPr>
+        <a:xfrm>
+          <a:off x="0" y="0"/>
+          <a:ext cx="0" cy="0"/>
+          <a:chOff x="0" y="0"/>
+          <a:chExt cx="0" cy="0"/>
+        </a:xfrm>
+      </p:grpSpPr>
+      <p:sp>
+        <p:nvSpPr>
+          <p:cNvPr id="2" name="Marcador de Posição da Imagem do Diapositivo 1">
+            <a:extLst>
+              <a:ext uri="{FF2B5EF4-FFF2-40B4-BE49-F238E27FC236}">
+                <a16:creationId xmlns:a16="http://schemas.microsoft.com/office/drawing/2014/main" id="{82B54D5D-CDA7-0157-77E7-1FDE8EDD9C48}"/>
+              </a:ext>
+            </a:extLst>
+          </p:cNvPr>
+          <p:cNvSpPr>
+            <a:spLocks noGrp="1" noRot="1" noChangeAspect="1"/>
+          </p:cNvSpPr>
+          <p:nvPr>
+            <p:ph type="sldImg"/>
+          </p:nvPr>
+        </p:nvSpPr>
+        <p:spPr/>
+      </p:sp>
+      <p:sp>
+        <p:nvSpPr>
+          <p:cNvPr id="3" name="Marcador de Posição de Notas 2">
+            <a:extLst>
+              <a:ext uri="{FF2B5EF4-FFF2-40B4-BE49-F238E27FC236}">
+                <a16:creationId xmlns:a16="http://schemas.microsoft.com/office/drawing/2014/main" id="{15DF8A04-46B2-BA00-FB5D-DACB585F0168}"/>
+              </a:ext>
+            </a:extLst>
+          </p:cNvPr>
+          <p:cNvSpPr>
+            <a:spLocks noGrp="1"/>
+          </p:cNvSpPr>
+          <p:nvPr>
+            <p:ph type="body" idx="1"/>
+          </p:nvPr>
+        </p:nvSpPr>
+        <p:spPr/>
+        <p:txBody>
+          <a:bodyPr/>
+          <a:lstStyle/>
+          <a:p>
+            <a:r>
+              <a:rPr lang="en-US" dirty="0"/>
+              <a:t>The practical advantages: it serves as a visual aid for medicinal chemists, increasing trust in ML predictions through transparency. </a:t>
+            </a:r>
+          </a:p>
+          <a:p>
+            <a:endParaRPr lang="en-US" dirty="0"/>
+          </a:p>
+          <a:p>
+            <a:r>
+              <a:rPr lang="en-US" dirty="0"/>
+              <a:t>It's fully integrated with an LLM, so it's ready to use. </a:t>
+            </a:r>
+          </a:p>
+          <a:p>
+            <a:endParaRPr lang="en-US" dirty="0"/>
+          </a:p>
+          <a:p>
+            <a:r>
+              <a:rPr lang="en-US" dirty="0"/>
+              <a:t>And it's built on open-source models, making it accessible and adaptable to different needs</a:t>
+            </a:r>
+            <a:endParaRPr lang="pt-PT" dirty="0"/>
+          </a:p>
+        </p:txBody>
+      </p:sp>
+      <p:sp>
+        <p:nvSpPr>
+          <p:cNvPr id="4" name="Marcador de Posição do Número do Diapositivo 3">
+            <a:extLst>
+              <a:ext uri="{FF2B5EF4-FFF2-40B4-BE49-F238E27FC236}">
+                <a16:creationId xmlns:a16="http://schemas.microsoft.com/office/drawing/2014/main" id="{A3FB29BA-E2DC-742B-7EFE-FDB07589800A}"/>
+              </a:ext>
+            </a:extLst>
+          </p:cNvPr>
+          <p:cNvSpPr>
+            <a:spLocks noGrp="1"/>
+          </p:cNvSpPr>
+          <p:nvPr>
+            <p:ph type="sldNum" sz="quarter" idx="5"/>
+          </p:nvPr>
+        </p:nvSpPr>
+        <p:spPr/>
+        <p:txBody>
+          <a:bodyPr/>
+          <a:lstStyle/>
+          <a:p>
+            <a:fld id="{A8F1D436-8E8C-482D-8D71-F0E649122FF1}" type="slidenum">
+              <a:rPr lang="de-DE" smtClean="0"/>
+              <a:t>10</a:t>
+            </a:fld>
+            <a:endParaRPr lang="de-DE"/>
+          </a:p>
+        </p:txBody>
+      </p:sp>
+    </p:spTree>
+    <p:extLst>
+      <p:ext uri="{BB962C8B-B14F-4D97-AF65-F5344CB8AC3E}">
+        <p14:creationId xmlns:p14="http://schemas.microsoft.com/office/powerpoint/2010/main" val="2535246732"/>
+      </p:ext>
+    </p:extLst>
+  </p:cSld>
+  <p:clrMapOvr>
+    <a:masterClrMapping/>
+  </p:clrMapOvr>
+</p:notes>
 </file>
 
 <file path=ppt/slideLayouts/slideLayout1.xml><?xml version="1.0" encoding="utf-8"?>
@@ -9358,7 +9994,7 @@
         <p:cNvPr id="1" name="">
           <a:extLst>
             <a:ext uri="{FF2B5EF4-FFF2-40B4-BE49-F238E27FC236}">
-              <a16:creationId xmlns:a16="http://schemas.microsoft.com/office/drawing/2014/main" id="{A6515F23-0912-A838-23CE-B8F00573A2DA}"/>
+              <a16:creationId xmlns:a16="http://schemas.microsoft.com/office/drawing/2014/main" id="{BBB5A1B2-7A92-53AE-94A1-C4092E55B578}"/>
             </a:ext>
           </a:extLst>
         </p:cNvPr>
@@ -9375,10 +10011,10 @@
       </p:grpSpPr>
       <p:sp>
         <p:nvSpPr>
-          <p:cNvPr id="163" name="PlaceHolder 1">
+          <p:cNvPr id="158" name="PlaceHolder 1">
             <a:extLst>
               <a:ext uri="{FF2B5EF4-FFF2-40B4-BE49-F238E27FC236}">
-                <a16:creationId xmlns:a16="http://schemas.microsoft.com/office/drawing/2014/main" id="{57944F4B-F502-E7CC-8790-8737702BC6AC}"/>
+                <a16:creationId xmlns:a16="http://schemas.microsoft.com/office/drawing/2014/main" id="{F4F64255-0CB6-D441-EB42-A827943DC4A3}"/>
               </a:ext>
             </a:extLst>
           </p:cNvPr>
@@ -9412,16 +10048,15 @@
               <a:lnSpc>
                 <a:spcPct val="100000"/>
               </a:lnSpc>
-              <a:buNone/>
             </a:pPr>
             <a:r>
-              <a:rPr lang="en-US" sz="3200" b="0" strike="noStrike" spc="-1" dirty="0">
+              <a:rPr lang="en-US" sz="3200" spc="-1" dirty="0">
                 <a:solidFill>
                   <a:srgbClr val="0064C8"/>
                 </a:solidFill>
                 <a:latin typeface="Century Gothic"/>
               </a:rPr>
-              <a:t>To do list</a:t>
+              <a:t>Agent Advantages and Improvements</a:t>
             </a:r>
             <a:endParaRPr lang="en-US" sz="3200" b="0" strike="noStrike" spc="-1" dirty="0">
               <a:solidFill>
@@ -9434,10 +10069,235 @@
       </p:sp>
       <p:sp>
         <p:nvSpPr>
-          <p:cNvPr id="165" name="PlaceHolder 3">
+          <p:cNvPr id="159" name="PlaceHolder 2">
             <a:extLst>
               <a:ext uri="{FF2B5EF4-FFF2-40B4-BE49-F238E27FC236}">
-                <a16:creationId xmlns:a16="http://schemas.microsoft.com/office/drawing/2014/main" id="{2EFBEA53-7B78-D9A1-93EF-9608A3193D27}"/>
+                <a16:creationId xmlns:a16="http://schemas.microsoft.com/office/drawing/2014/main" id="{D59FF44B-6222-67BD-CD20-4D01B6DF9761}"/>
+              </a:ext>
+            </a:extLst>
+          </p:cNvPr>
+          <p:cNvSpPr>
+            <a:spLocks noGrp="1"/>
+          </p:cNvSpPr>
+          <p:nvPr>
+            <p:ph/>
+          </p:nvPr>
+        </p:nvSpPr>
+        <p:spPr>
+          <a:xfrm>
+            <a:off x="382679" y="1371600"/>
+            <a:ext cx="8378281" cy="4321079"/>
+          </a:xfrm>
+          <a:prstGeom prst="rect">
+            <a:avLst/>
+          </a:prstGeom>
+          <a:noFill/>
+          <a:ln w="0">
+            <a:noFill/>
+          </a:ln>
+        </p:spPr>
+        <p:txBody>
+          <a:bodyPr numCol="1" spcCol="0" anchor="t">
+            <a:noAutofit/>
+          </a:bodyPr>
+          <a:lstStyle/>
+          <a:p>
+            <a:pPr marL="0" indent="0">
+              <a:spcBef>
+                <a:spcPts val="400"/>
+              </a:spcBef>
+              <a:spcAft>
+                <a:spcPts val="2400"/>
+              </a:spcAft>
+              <a:buClr>
+                <a:srgbClr val="0070C0"/>
+              </a:buClr>
+              <a:buNone/>
+            </a:pPr>
+            <a:r>
+              <a:rPr lang="en-US" sz="2000" b="1" strike="noStrike" spc="-1" dirty="0">
+                <a:latin typeface="Century Gothic"/>
+              </a:rPr>
+              <a:t>Practical advantages</a:t>
+            </a:r>
+            <a:r>
+              <a:rPr lang="en-US" sz="2000" strike="noStrike" spc="-1" dirty="0">
+                <a:latin typeface="Century Gothic"/>
+              </a:rPr>
+              <a:t> </a:t>
+            </a:r>
+          </a:p>
+          <a:p>
+            <a:pPr>
+              <a:spcBef>
+                <a:spcPts val="400"/>
+              </a:spcBef>
+              <a:spcAft>
+                <a:spcPts val="2400"/>
+              </a:spcAft>
+              <a:buClr>
+                <a:srgbClr val="0070C0"/>
+              </a:buClr>
+              <a:buFont typeface="Wingdings" panose="05000000000000000000" pitchFamily="2" charset="2"/>
+              <a:buChar char="§"/>
+            </a:pPr>
+            <a:r>
+              <a:rPr lang="en-US" sz="1800" spc="-1" dirty="0">
+                <a:latin typeface="Century Gothic"/>
+              </a:rPr>
+              <a:t>Visual aid for chemists → Increase transparency in ML predictions  </a:t>
+            </a:r>
+          </a:p>
+          <a:p>
+            <a:pPr>
+              <a:spcBef>
+                <a:spcPts val="400"/>
+              </a:spcBef>
+              <a:spcAft>
+                <a:spcPts val="2400"/>
+              </a:spcAft>
+              <a:buClr>
+                <a:srgbClr val="0070C0"/>
+              </a:buClr>
+              <a:buFont typeface="Wingdings" panose="05000000000000000000" pitchFamily="2" charset="2"/>
+              <a:buChar char="§"/>
+            </a:pPr>
+            <a:r>
+              <a:rPr lang="en-US" sz="1800" spc="-1" dirty="0">
+                <a:latin typeface="Century Gothic"/>
+              </a:rPr>
+              <a:t>Built on Open-source LLMs → Accessible to the community</a:t>
+            </a:r>
+          </a:p>
+          <a:p>
+            <a:pPr marL="0" indent="0">
+              <a:spcBef>
+                <a:spcPts val="400"/>
+              </a:spcBef>
+              <a:spcAft>
+                <a:spcPts val="2400"/>
+              </a:spcAft>
+              <a:buClr>
+                <a:srgbClr val="0070C0"/>
+              </a:buClr>
+              <a:buNone/>
+            </a:pPr>
+            <a:r>
+              <a:rPr lang="en-US" sz="2000" b="1" spc="-1" dirty="0">
+                <a:latin typeface="Century Gothic"/>
+              </a:rPr>
+              <a:t>Points to evaluate and improve</a:t>
+            </a:r>
+          </a:p>
+          <a:p>
+            <a:pPr>
+              <a:spcBef>
+                <a:spcPts val="400"/>
+              </a:spcBef>
+              <a:spcAft>
+                <a:spcPts val="2400"/>
+              </a:spcAft>
+              <a:buClr>
+                <a:srgbClr val="0070C0"/>
+              </a:buClr>
+              <a:buFont typeface="Wingdings" panose="05000000000000000000" pitchFamily="2" charset="2"/>
+              <a:buChar char="§"/>
+            </a:pPr>
+            <a:r>
+              <a:rPr lang="en-US" sz="1800" spc="-1" dirty="0">
+                <a:latin typeface="Century Gothic"/>
+              </a:rPr>
+              <a:t>Susceptibility to LLM hallucinations →  Use domain-specific models</a:t>
+            </a:r>
+            <a:endParaRPr lang="en-US" sz="1800" b="1" spc="-1" dirty="0">
+              <a:latin typeface="Century Gothic"/>
+            </a:endParaRPr>
+          </a:p>
+          <a:p>
+            <a:pPr>
+              <a:spcBef>
+                <a:spcPts val="400"/>
+              </a:spcBef>
+              <a:spcAft>
+                <a:spcPts val="2400"/>
+              </a:spcAft>
+              <a:buClr>
+                <a:srgbClr val="0070C0"/>
+              </a:buClr>
+              <a:buFont typeface="Wingdings" panose="05000000000000000000" pitchFamily="2" charset="2"/>
+              <a:buChar char="§"/>
+            </a:pPr>
+            <a:r>
+              <a:rPr lang="en-US" sz="1800" spc="-1" dirty="0">
+                <a:latin typeface="Century Gothic"/>
+              </a:rPr>
+              <a:t>Requires careful prompt curation → Addition of interactive chat feature</a:t>
+            </a:r>
+            <a:endParaRPr lang="en-US" sz="1800" b="1" spc="-1" dirty="0">
+              <a:latin typeface="Century Gothic"/>
+            </a:endParaRPr>
+          </a:p>
+          <a:p>
+            <a:pPr>
+              <a:spcBef>
+                <a:spcPts val="400"/>
+              </a:spcBef>
+              <a:spcAft>
+                <a:spcPts val="2400"/>
+              </a:spcAft>
+              <a:buClr>
+                <a:srgbClr val="0070C0"/>
+              </a:buClr>
+              <a:buFont typeface="Wingdings" panose="05000000000000000000" pitchFamily="2" charset="2"/>
+              <a:buChar char="§"/>
+            </a:pPr>
+            <a:endParaRPr lang="en-US" sz="1800" spc="-1" dirty="0">
+              <a:latin typeface="Century Gothic"/>
+            </a:endParaRPr>
+          </a:p>
+          <a:p>
+            <a:pPr marL="0" indent="0">
+              <a:spcBef>
+                <a:spcPts val="400"/>
+              </a:spcBef>
+              <a:spcAft>
+                <a:spcPts val="2400"/>
+              </a:spcAft>
+              <a:buClr>
+                <a:srgbClr val="0070C0"/>
+              </a:buClr>
+              <a:buNone/>
+            </a:pPr>
+            <a:endParaRPr lang="en-US" sz="2000" spc="-1" dirty="0">
+              <a:latin typeface="Century Gothic"/>
+            </a:endParaRPr>
+          </a:p>
+          <a:p>
+            <a:pPr lvl="1">
+              <a:spcBef>
+                <a:spcPts val="400"/>
+              </a:spcBef>
+              <a:spcAft>
+                <a:spcPts val="2400"/>
+              </a:spcAft>
+              <a:buClr>
+                <a:srgbClr val="0070C0"/>
+              </a:buClr>
+              <a:buFont typeface="Wingdings" panose="05000000000000000000" pitchFamily="2" charset="2"/>
+              <a:buChar char="§"/>
+            </a:pPr>
+            <a:endParaRPr lang="en-US" sz="1400" strike="noStrike" spc="-1" dirty="0">
+              <a:latin typeface="Century Gothic"/>
+            </a:endParaRPr>
+          </a:p>
+        </p:txBody>
+      </p:sp>
+      <p:sp>
+        <p:nvSpPr>
+          <p:cNvPr id="160" name="PlaceHolder 3">
+            <a:extLst>
+              <a:ext uri="{FF2B5EF4-FFF2-40B4-BE49-F238E27FC236}">
+                <a16:creationId xmlns:a16="http://schemas.microsoft.com/office/drawing/2014/main" id="{0DF1A3F0-772D-A247-0D44-2C215E694721}"/>
               </a:ext>
             </a:extLst>
           </p:cNvPr>
@@ -9473,7 +10333,7 @@
               </a:lnSpc>
               <a:buNone/>
             </a:pPr>
-            <a:fld id="{8BD7C522-1E12-40C3-B25E-5F0462E20B22}" type="slidenum">
+            <a:fld id="{7D48D3EA-1A87-4EB3-8072-3AEE88103579}" type="slidenum">
               <a:rPr lang="en-US" sz="1200" b="0" strike="noStrike" spc="-1">
                 <a:solidFill>
                   <a:srgbClr val="8B8B8B"/>
@@ -9482,474 +10342,8 @@
               </a:rPr>
               <a:t>10</a:t>
             </a:fld>
-            <a:endParaRPr lang="en-GB" sz="1200" b="0" strike="noStrike" spc="-1" dirty="0">
+            <a:endParaRPr lang="en-GB" sz="1200" b="0" strike="noStrike" spc="-1">
               <a:latin typeface="Times New Roman"/>
-            </a:endParaRPr>
-          </a:p>
-        </p:txBody>
-      </p:sp>
-      <p:sp>
-        <p:nvSpPr>
-          <p:cNvPr id="7" name="PlaceHolder 2">
-            <a:extLst>
-              <a:ext uri="{FF2B5EF4-FFF2-40B4-BE49-F238E27FC236}">
-                <a16:creationId xmlns:a16="http://schemas.microsoft.com/office/drawing/2014/main" id="{66DE14D4-64D4-6D1F-DD92-BC16D674C58B}"/>
-              </a:ext>
-            </a:extLst>
-          </p:cNvPr>
-          <p:cNvSpPr txBox="1">
-            <a:spLocks/>
-          </p:cNvSpPr>
-          <p:nvPr/>
-        </p:nvSpPr>
-        <p:spPr>
-          <a:xfrm>
-            <a:off x="380880" y="1371598"/>
-            <a:ext cx="8109070" cy="4559301"/>
-          </a:xfrm>
-          <a:prstGeom prst="rect">
-            <a:avLst/>
-          </a:prstGeom>
-          <a:noFill/>
-          <a:ln w="0">
-            <a:noFill/>
-          </a:ln>
-        </p:spPr>
-        <p:txBody>
-          <a:bodyPr numCol="1" spcCol="0" anchor="t">
-            <a:noAutofit/>
-          </a:bodyPr>
-          <a:lstStyle>
-            <a:lvl1pPr marL="228600" indent="-228600" algn="l" defTabSz="914400" rtl="0" eaLnBrk="1" latinLnBrk="0" hangingPunct="1">
-              <a:lnSpc>
-                <a:spcPct val="90000"/>
-              </a:lnSpc>
-              <a:spcBef>
-                <a:spcPts val="1000"/>
-              </a:spcBef>
-              <a:buFont typeface="Arial" panose="020B0604020202020204" pitchFamily="34" charset="0"/>
-              <a:buChar char="•"/>
-              <a:defRPr sz="2800" kern="1200">
-                <a:solidFill>
-                  <a:schemeClr val="tx1"/>
-                </a:solidFill>
-                <a:latin typeface="+mn-lt"/>
-                <a:ea typeface="+mn-ea"/>
-                <a:cs typeface="+mn-cs"/>
-              </a:defRPr>
-            </a:lvl1pPr>
-            <a:lvl2pPr marL="685800" indent="-228600" algn="l" defTabSz="914400" rtl="0" eaLnBrk="1" latinLnBrk="0" hangingPunct="1">
-              <a:lnSpc>
-                <a:spcPct val="90000"/>
-              </a:lnSpc>
-              <a:spcBef>
-                <a:spcPts val="500"/>
-              </a:spcBef>
-              <a:buFont typeface="Arial" panose="020B0604020202020204" pitchFamily="34" charset="0"/>
-              <a:buChar char="•"/>
-              <a:defRPr sz="2400" kern="1200">
-                <a:solidFill>
-                  <a:schemeClr val="tx1"/>
-                </a:solidFill>
-                <a:latin typeface="+mn-lt"/>
-                <a:ea typeface="+mn-ea"/>
-                <a:cs typeface="+mn-cs"/>
-              </a:defRPr>
-            </a:lvl2pPr>
-            <a:lvl3pPr marL="1143000" indent="-228600" algn="l" defTabSz="914400" rtl="0" eaLnBrk="1" latinLnBrk="0" hangingPunct="1">
-              <a:lnSpc>
-                <a:spcPct val="90000"/>
-              </a:lnSpc>
-              <a:spcBef>
-                <a:spcPts val="500"/>
-              </a:spcBef>
-              <a:buFont typeface="Arial" panose="020B0604020202020204" pitchFamily="34" charset="0"/>
-              <a:buChar char="•"/>
-              <a:defRPr sz="2000" kern="1200">
-                <a:solidFill>
-                  <a:schemeClr val="tx1"/>
-                </a:solidFill>
-                <a:latin typeface="+mn-lt"/>
-                <a:ea typeface="+mn-ea"/>
-                <a:cs typeface="+mn-cs"/>
-              </a:defRPr>
-            </a:lvl3pPr>
-            <a:lvl4pPr marL="1600200" indent="-228600" algn="l" defTabSz="914400" rtl="0" eaLnBrk="1" latinLnBrk="0" hangingPunct="1">
-              <a:lnSpc>
-                <a:spcPct val="90000"/>
-              </a:lnSpc>
-              <a:spcBef>
-                <a:spcPts val="500"/>
-              </a:spcBef>
-              <a:buFont typeface="Arial" panose="020B0604020202020204" pitchFamily="34" charset="0"/>
-              <a:buChar char="•"/>
-              <a:defRPr sz="1800" kern="1200">
-                <a:solidFill>
-                  <a:schemeClr val="tx1"/>
-                </a:solidFill>
-                <a:latin typeface="+mn-lt"/>
-                <a:ea typeface="+mn-ea"/>
-                <a:cs typeface="+mn-cs"/>
-              </a:defRPr>
-            </a:lvl4pPr>
-            <a:lvl5pPr marL="2057400" indent="-228600" algn="l" defTabSz="914400" rtl="0" eaLnBrk="1" latinLnBrk="0" hangingPunct="1">
-              <a:lnSpc>
-                <a:spcPct val="90000"/>
-              </a:lnSpc>
-              <a:spcBef>
-                <a:spcPts val="500"/>
-              </a:spcBef>
-              <a:buFont typeface="Arial" panose="020B0604020202020204" pitchFamily="34" charset="0"/>
-              <a:buChar char="•"/>
-              <a:defRPr sz="1800" kern="1200">
-                <a:solidFill>
-                  <a:schemeClr val="tx1"/>
-                </a:solidFill>
-                <a:latin typeface="+mn-lt"/>
-                <a:ea typeface="+mn-ea"/>
-                <a:cs typeface="+mn-cs"/>
-              </a:defRPr>
-            </a:lvl5pPr>
-            <a:lvl6pPr marL="2514600" indent="-228600" algn="l" defTabSz="914400" rtl="0" eaLnBrk="1" latinLnBrk="0" hangingPunct="1">
-              <a:lnSpc>
-                <a:spcPct val="90000"/>
-              </a:lnSpc>
-              <a:spcBef>
-                <a:spcPts val="500"/>
-              </a:spcBef>
-              <a:buFont typeface="Arial" panose="020B0604020202020204" pitchFamily="34" charset="0"/>
-              <a:buChar char="•"/>
-              <a:defRPr sz="1800" kern="1200">
-                <a:solidFill>
-                  <a:schemeClr val="tx1"/>
-                </a:solidFill>
-                <a:latin typeface="+mn-lt"/>
-                <a:ea typeface="+mn-ea"/>
-                <a:cs typeface="+mn-cs"/>
-              </a:defRPr>
-            </a:lvl6pPr>
-            <a:lvl7pPr marL="2971800" indent="-228600" algn="l" defTabSz="914400" rtl="0" eaLnBrk="1" latinLnBrk="0" hangingPunct="1">
-              <a:lnSpc>
-                <a:spcPct val="90000"/>
-              </a:lnSpc>
-              <a:spcBef>
-                <a:spcPts val="500"/>
-              </a:spcBef>
-              <a:buFont typeface="Arial" panose="020B0604020202020204" pitchFamily="34" charset="0"/>
-              <a:buChar char="•"/>
-              <a:defRPr sz="1800" kern="1200">
-                <a:solidFill>
-                  <a:schemeClr val="tx1"/>
-                </a:solidFill>
-                <a:latin typeface="+mn-lt"/>
-                <a:ea typeface="+mn-ea"/>
-                <a:cs typeface="+mn-cs"/>
-              </a:defRPr>
-            </a:lvl7pPr>
-            <a:lvl8pPr marL="3429000" indent="-228600" algn="l" defTabSz="914400" rtl="0" eaLnBrk="1" latinLnBrk="0" hangingPunct="1">
-              <a:lnSpc>
-                <a:spcPct val="90000"/>
-              </a:lnSpc>
-              <a:spcBef>
-                <a:spcPts val="500"/>
-              </a:spcBef>
-              <a:buFont typeface="Arial" panose="020B0604020202020204" pitchFamily="34" charset="0"/>
-              <a:buChar char="•"/>
-              <a:defRPr sz="1800" kern="1200">
-                <a:solidFill>
-                  <a:schemeClr val="tx1"/>
-                </a:solidFill>
-                <a:latin typeface="+mn-lt"/>
-                <a:ea typeface="+mn-ea"/>
-                <a:cs typeface="+mn-cs"/>
-              </a:defRPr>
-            </a:lvl8pPr>
-            <a:lvl9pPr marL="3886200" indent="-228600" algn="l" defTabSz="914400" rtl="0" eaLnBrk="1" latinLnBrk="0" hangingPunct="1">
-              <a:lnSpc>
-                <a:spcPct val="90000"/>
-              </a:lnSpc>
-              <a:spcBef>
-                <a:spcPts val="500"/>
-              </a:spcBef>
-              <a:buFont typeface="Arial" panose="020B0604020202020204" pitchFamily="34" charset="0"/>
-              <a:buChar char="•"/>
-              <a:defRPr sz="1800" kern="1200">
-                <a:solidFill>
-                  <a:schemeClr val="tx1"/>
-                </a:solidFill>
-                <a:latin typeface="+mn-lt"/>
-                <a:ea typeface="+mn-ea"/>
-                <a:cs typeface="+mn-cs"/>
-              </a:defRPr>
-            </a:lvl9pPr>
-          </a:lstStyle>
-          <a:p>
-            <a:pPr>
-              <a:lnSpc>
-                <a:spcPct val="100000"/>
-              </a:lnSpc>
-              <a:spcBef>
-                <a:spcPts val="400"/>
-              </a:spcBef>
-              <a:buClr>
-                <a:srgbClr val="0064C8"/>
-              </a:buClr>
-              <a:buFont typeface="Wingdings" panose="05000000000000000000" pitchFamily="2" charset="2"/>
-              <a:buChar char="§"/>
-            </a:pPr>
-            <a:r>
-              <a:rPr lang="en-US" sz="2000" spc="-1" dirty="0">
-                <a:solidFill>
-                  <a:srgbClr val="000000"/>
-                </a:solidFill>
-                <a:latin typeface="Century Gothic"/>
-              </a:rPr>
-              <a:t>Integrate with cluster for faster inference and explore larger LLMs</a:t>
-            </a:r>
-          </a:p>
-          <a:p>
-            <a:pPr>
-              <a:lnSpc>
-                <a:spcPct val="100000"/>
-              </a:lnSpc>
-              <a:spcBef>
-                <a:spcPts val="400"/>
-              </a:spcBef>
-              <a:buClr>
-                <a:srgbClr val="0064C8"/>
-              </a:buClr>
-              <a:buFont typeface="Wingdings" panose="05000000000000000000" pitchFamily="2" charset="2"/>
-              <a:buChar char="§"/>
-            </a:pPr>
-            <a:endParaRPr lang="en-US" sz="2000" spc="-1" dirty="0">
-              <a:solidFill>
-                <a:srgbClr val="000000"/>
-              </a:solidFill>
-              <a:latin typeface="Century Gothic"/>
-            </a:endParaRPr>
-          </a:p>
-          <a:p>
-            <a:pPr lvl="1">
-              <a:lnSpc>
-                <a:spcPct val="100000"/>
-              </a:lnSpc>
-              <a:spcBef>
-                <a:spcPts val="400"/>
-              </a:spcBef>
-              <a:buClr>
-                <a:srgbClr val="0064C8"/>
-              </a:buClr>
-              <a:buFont typeface="Wingdings" panose="05000000000000000000" pitchFamily="2" charset="2"/>
-              <a:buChar char="§"/>
-            </a:pPr>
-            <a:r>
-              <a:rPr lang="en-US" sz="1600" spc="-1" dirty="0">
-                <a:solidFill>
-                  <a:srgbClr val="000000"/>
-                </a:solidFill>
-                <a:latin typeface="Century Gothic"/>
-              </a:rPr>
-              <a:t>It works already on the workstations with medium-to-large LLMs</a:t>
-            </a:r>
-          </a:p>
-          <a:p>
-            <a:pPr marL="0" indent="0">
-              <a:lnSpc>
-                <a:spcPct val="100000"/>
-              </a:lnSpc>
-              <a:spcBef>
-                <a:spcPts val="400"/>
-              </a:spcBef>
-              <a:buClr>
-                <a:srgbClr val="0064C8"/>
-              </a:buClr>
-              <a:buNone/>
-            </a:pPr>
-            <a:endParaRPr lang="en-US" sz="2000" spc="-1" dirty="0">
-              <a:solidFill>
-                <a:srgbClr val="000000"/>
-              </a:solidFill>
-              <a:latin typeface="Century Gothic"/>
-            </a:endParaRPr>
-          </a:p>
-          <a:p>
-            <a:pPr>
-              <a:lnSpc>
-                <a:spcPct val="100000"/>
-              </a:lnSpc>
-              <a:spcBef>
-                <a:spcPts val="400"/>
-              </a:spcBef>
-              <a:buClr>
-                <a:srgbClr val="0064C8"/>
-              </a:buClr>
-              <a:buFont typeface="Wingdings" panose="05000000000000000000" pitchFamily="2" charset="2"/>
-              <a:buChar char="§"/>
-            </a:pPr>
-            <a:r>
-              <a:rPr lang="en-US" sz="2000" spc="-1" dirty="0">
-                <a:solidFill>
-                  <a:srgbClr val="000000"/>
-                </a:solidFill>
-                <a:latin typeface="Century Gothic"/>
-              </a:rPr>
-              <a:t>Clean up the repository and make it available </a:t>
-            </a:r>
-          </a:p>
-          <a:p>
-            <a:pPr>
-              <a:lnSpc>
-                <a:spcPct val="100000"/>
-              </a:lnSpc>
-              <a:spcBef>
-                <a:spcPts val="400"/>
-              </a:spcBef>
-              <a:buClr>
-                <a:srgbClr val="0064C8"/>
-              </a:buClr>
-              <a:buFont typeface="Wingdings" panose="05000000000000000000" pitchFamily="2" charset="2"/>
-              <a:buChar char="§"/>
-            </a:pPr>
-            <a:endParaRPr lang="en-US" sz="2000" spc="-1" dirty="0">
-              <a:solidFill>
-                <a:srgbClr val="000000"/>
-              </a:solidFill>
-              <a:latin typeface="Century Gothic"/>
-            </a:endParaRPr>
-          </a:p>
-          <a:p>
-            <a:pPr lvl="1">
-              <a:lnSpc>
-                <a:spcPct val="100000"/>
-              </a:lnSpc>
-              <a:spcBef>
-                <a:spcPts val="400"/>
-              </a:spcBef>
-              <a:buClr>
-                <a:srgbClr val="0064C8"/>
-              </a:buClr>
-              <a:buFont typeface="Wingdings" panose="05000000000000000000" pitchFamily="2" charset="2"/>
-              <a:buChar char="§"/>
-            </a:pPr>
-            <a:r>
-              <a:rPr lang="en-US" sz="1600" spc="-1" dirty="0">
-                <a:solidFill>
-                  <a:srgbClr val="000000"/>
-                </a:solidFill>
-                <a:latin typeface="Century Gothic"/>
-              </a:rPr>
-              <a:t>An “organization repository” is available for the whole lab to ease the integration of new components</a:t>
-            </a:r>
-          </a:p>
-          <a:p>
-            <a:pPr>
-              <a:lnSpc>
-                <a:spcPct val="100000"/>
-              </a:lnSpc>
-              <a:spcBef>
-                <a:spcPts val="400"/>
-              </a:spcBef>
-              <a:buClr>
-                <a:srgbClr val="0064C8"/>
-              </a:buClr>
-              <a:buFont typeface="Wingdings" panose="05000000000000000000" pitchFamily="2" charset="2"/>
-              <a:buChar char="§"/>
-            </a:pPr>
-            <a:endParaRPr lang="en-US" sz="2000" spc="-1" dirty="0">
-              <a:solidFill>
-                <a:srgbClr val="000000"/>
-              </a:solidFill>
-              <a:latin typeface="Century Gothic"/>
-            </a:endParaRPr>
-          </a:p>
-          <a:p>
-            <a:pPr>
-              <a:lnSpc>
-                <a:spcPct val="100000"/>
-              </a:lnSpc>
-              <a:spcBef>
-                <a:spcPts val="400"/>
-              </a:spcBef>
-              <a:buClr>
-                <a:srgbClr val="0064C8"/>
-              </a:buClr>
-              <a:buFont typeface="Wingdings" panose="05000000000000000000" pitchFamily="2" charset="2"/>
-              <a:buChar char="§"/>
-            </a:pPr>
-            <a:r>
-              <a:rPr lang="en-US" sz="2000" spc="-1" dirty="0">
-                <a:solidFill>
-                  <a:srgbClr val="000000"/>
-                </a:solidFill>
-                <a:latin typeface="Century Gothic"/>
-              </a:rPr>
-              <a:t>Make a guide for lab members for the implementation of AI agents</a:t>
-            </a:r>
-          </a:p>
-          <a:p>
-            <a:pPr>
-              <a:lnSpc>
-                <a:spcPct val="100000"/>
-              </a:lnSpc>
-              <a:spcBef>
-                <a:spcPts val="400"/>
-              </a:spcBef>
-              <a:buClr>
-                <a:srgbClr val="0064C8"/>
-              </a:buClr>
-              <a:buFont typeface="Wingdings" panose="05000000000000000000" pitchFamily="2" charset="2"/>
-              <a:buChar char="§"/>
-            </a:pPr>
-            <a:endParaRPr lang="en-US" sz="2000" spc="-1" dirty="0">
-              <a:solidFill>
-                <a:srgbClr val="000000"/>
-              </a:solidFill>
-              <a:latin typeface="Century Gothic"/>
-            </a:endParaRPr>
-          </a:p>
-          <a:p>
-            <a:pPr>
-              <a:lnSpc>
-                <a:spcPct val="100000"/>
-              </a:lnSpc>
-              <a:spcBef>
-                <a:spcPts val="400"/>
-              </a:spcBef>
-              <a:buClr>
-                <a:srgbClr val="0064C8"/>
-              </a:buClr>
-              <a:buFont typeface="Wingdings" panose="05000000000000000000" pitchFamily="2" charset="2"/>
-              <a:buChar char="§"/>
-            </a:pPr>
-            <a:endParaRPr lang="en-US" sz="1800" spc="-1" dirty="0">
-              <a:solidFill>
-                <a:srgbClr val="000000"/>
-              </a:solidFill>
-              <a:latin typeface="Century Gothic"/>
-            </a:endParaRPr>
-          </a:p>
-          <a:p>
-            <a:pPr marL="343080" indent="-343080">
-              <a:lnSpc>
-                <a:spcPct val="100000"/>
-              </a:lnSpc>
-              <a:spcBef>
-                <a:spcPts val="400"/>
-              </a:spcBef>
-              <a:spcAft>
-                <a:spcPts val="601"/>
-              </a:spcAft>
-              <a:buClr>
-                <a:srgbClr val="0064C8"/>
-              </a:buClr>
-              <a:buFont typeface="Wingdings 2" charset="2"/>
-              <a:buChar char=""/>
-            </a:pPr>
-            <a:endParaRPr lang="en-US" sz="2000" b="1" spc="-1" dirty="0">
-              <a:solidFill>
-                <a:srgbClr val="000000"/>
-              </a:solidFill>
-              <a:latin typeface="Century Gothic"/>
             </a:endParaRPr>
           </a:p>
         </p:txBody>
@@ -9957,7 +10351,7 @@
     </p:spTree>
     <p:extLst>
       <p:ext uri="{BB962C8B-B14F-4D97-AF65-F5344CB8AC3E}">
-        <p14:creationId xmlns:p14="http://schemas.microsoft.com/office/powerpoint/2010/main" val="3727029337"/>
+        <p14:creationId xmlns:p14="http://schemas.microsoft.com/office/powerpoint/2010/main" val="2674446027"/>
       </p:ext>
     </p:extLst>
   </p:cSld>
@@ -10038,7 +10432,7 @@
                 </a:solidFill>
                 <a:latin typeface="Century Gothic"/>
               </a:rPr>
-              <a:t>Framing</a:t>
+              <a:t>To do list</a:t>
             </a:r>
             <a:endParaRPr lang="en-US" sz="3200" b="0" strike="noStrike" spc="-1" dirty="0">
               <a:solidFill>
@@ -10321,8 +10715,29 @@
                 </a:solidFill>
                 <a:latin typeface="Century Gothic"/>
               </a:rPr>
-              <a:t>How to frame the project:</a:t>
+              <a:t>Integrate with cluster for faster inference and explore larger LLMs</a:t>
             </a:r>
+          </a:p>
+          <a:p>
+            <a:pPr>
+              <a:lnSpc>
+                <a:spcPct val="100000"/>
+              </a:lnSpc>
+              <a:spcBef>
+                <a:spcPts val="400"/>
+              </a:spcBef>
+              <a:buClr>
+                <a:srgbClr val="0064C8"/>
+              </a:buClr>
+              <a:buFont typeface="Wingdings" panose="05000000000000000000" pitchFamily="2" charset="2"/>
+              <a:buChar char="§"/>
+            </a:pPr>
+            <a:endParaRPr lang="en-US" sz="2000" spc="-1" dirty="0">
+              <a:solidFill>
+                <a:srgbClr val="000000"/>
+              </a:solidFill>
+              <a:latin typeface="Century Gothic"/>
+            </a:endParaRPr>
           </a:p>
           <a:p>
             <a:pPr lvl="1">
@@ -10345,8 +10760,73 @@
                 </a:solidFill>
                 <a:latin typeface="Century Gothic"/>
               </a:rPr>
-              <a:t>A proof-of-concept study?</a:t>
+              <a:t>It works already on the workstations with medium-to-large LLMs</a:t>
             </a:r>
+          </a:p>
+          <a:p>
+            <a:pPr marL="0" indent="0">
+              <a:lnSpc>
+                <a:spcPct val="100000"/>
+              </a:lnSpc>
+              <a:spcBef>
+                <a:spcPts val="400"/>
+              </a:spcBef>
+              <a:buClr>
+                <a:srgbClr val="0064C8"/>
+              </a:buClr>
+              <a:buNone/>
+            </a:pPr>
+            <a:endParaRPr lang="en-US" sz="2000" spc="-1" dirty="0">
+              <a:solidFill>
+                <a:srgbClr val="000000"/>
+              </a:solidFill>
+              <a:latin typeface="Century Gothic"/>
+            </a:endParaRPr>
+          </a:p>
+          <a:p>
+            <a:pPr>
+              <a:lnSpc>
+                <a:spcPct val="100000"/>
+              </a:lnSpc>
+              <a:spcBef>
+                <a:spcPts val="400"/>
+              </a:spcBef>
+              <a:buClr>
+                <a:srgbClr val="0064C8"/>
+              </a:buClr>
+              <a:buFont typeface="Wingdings" panose="05000000000000000000" pitchFamily="2" charset="2"/>
+              <a:buChar char="§"/>
+            </a:pPr>
+            <a:r>
+              <a:rPr lang="en-US" sz="2000" spc="-1" dirty="0">
+                <a:solidFill>
+                  <a:srgbClr val="000000"/>
+                </a:solidFill>
+                <a:latin typeface="Century Gothic"/>
+              </a:rPr>
+              <a:t>Clean up the repository and make it available </a:t>
+            </a:r>
+          </a:p>
+          <a:p>
+            <a:pPr>
+              <a:lnSpc>
+                <a:spcPct val="100000"/>
+              </a:lnSpc>
+              <a:spcBef>
+                <a:spcPts val="400"/>
+              </a:spcBef>
+              <a:buClr>
+                <a:srgbClr val="0064C8"/>
+              </a:buClr>
+              <a:buFont typeface="Wingdings" panose="05000000000000000000" pitchFamily="2" charset="2"/>
+              <a:buChar char="§"/>
+            </a:pPr>
+            <a:endParaRPr lang="en-US" sz="2000" spc="-1" dirty="0">
+              <a:solidFill>
+                <a:srgbClr val="000000"/>
+              </a:solidFill>
+              <a:latin typeface="Century Gothic"/>
+            </a:endParaRPr>
           </a:p>
           <a:p>
             <a:pPr lvl="1">
@@ -10369,11 +10849,32 @@
                 </a:solidFill>
                 <a:latin typeface="Century Gothic"/>
               </a:rPr>
-              <a:t>An explainability platform for XAI applied to molecular design?</a:t>
+              <a:t>An “organization repository” is available for the whole lab to ease the integration of new components</a:t>
             </a:r>
           </a:p>
           <a:p>
-            <a:pPr lvl="1">
+            <a:pPr>
+              <a:lnSpc>
+                <a:spcPct val="100000"/>
+              </a:lnSpc>
+              <a:spcBef>
+                <a:spcPts val="400"/>
+              </a:spcBef>
+              <a:buClr>
+                <a:srgbClr val="0064C8"/>
+              </a:buClr>
+              <a:buFont typeface="Wingdings" panose="05000000000000000000" pitchFamily="2" charset="2"/>
+              <a:buChar char="§"/>
+            </a:pPr>
+            <a:endParaRPr lang="en-US" sz="2000" spc="-1" dirty="0">
+              <a:solidFill>
+                <a:srgbClr val="000000"/>
+              </a:solidFill>
+              <a:latin typeface="Century Gothic"/>
+            </a:endParaRPr>
+          </a:p>
+          <a:p>
+            <a:pPr>
               <a:lnSpc>
                 <a:spcPct val="100000"/>
               </a:lnSpc>
@@ -10387,116 +10888,14 @@
               <a:buChar char="§"/>
             </a:pPr>
             <a:r>
-              <a:rPr lang="en-US" sz="1600" spc="-1" dirty="0">
+              <a:rPr lang="en-US" sz="2000" spc="-1" dirty="0">
                 <a:solidFill>
                   <a:srgbClr val="000000"/>
                 </a:solidFill>
                 <a:latin typeface="Century Gothic"/>
               </a:rPr>
-              <a:t>An explainability platform for XAI specific to molecular selectivity?</a:t>
+              <a:t>Make a guide for lab members for the implementation of AI agents</a:t>
             </a:r>
-          </a:p>
-          <a:p>
-            <a:pPr lvl="1">
-              <a:lnSpc>
-                <a:spcPct val="100000"/>
-              </a:lnSpc>
-              <a:spcBef>
-                <a:spcPts val="400"/>
-              </a:spcBef>
-              <a:buClr>
-                <a:srgbClr val="0064C8"/>
-              </a:buClr>
-              <a:buFont typeface="Wingdings" panose="05000000000000000000" pitchFamily="2" charset="2"/>
-              <a:buChar char="§"/>
-            </a:pPr>
-            <a:r>
-              <a:rPr lang="en-US" sz="1600" spc="-1" dirty="0">
-                <a:solidFill>
-                  <a:srgbClr val="000000"/>
-                </a:solidFill>
-                <a:latin typeface="Century Gothic"/>
-              </a:rPr>
-              <a:t>A modular </a:t>
-            </a:r>
-            <a:r>
-              <a:rPr lang="en-US" sz="1600" spc="-1" dirty="0" err="1">
-                <a:solidFill>
-                  <a:srgbClr val="000000"/>
-                </a:solidFill>
-                <a:latin typeface="Century Gothic"/>
-              </a:rPr>
-              <a:t>explainability</a:t>
-            </a:r>
-            <a:r>
-              <a:rPr lang="en-US" sz="1600" spc="-1" dirty="0">
-                <a:solidFill>
-                  <a:srgbClr val="000000"/>
-                </a:solidFill>
-                <a:latin typeface="Century Gothic"/>
-              </a:rPr>
-              <a:t>-enhanced platform for </a:t>
-            </a:r>
-            <a:r>
-              <a:rPr lang="en-US" sz="1600" spc="-1" dirty="0" err="1">
-                <a:solidFill>
-                  <a:srgbClr val="000000"/>
-                </a:solidFill>
-                <a:latin typeface="Century Gothic"/>
-              </a:rPr>
-              <a:t>chemoinformatics</a:t>
-            </a:r>
-            <a:r>
-              <a:rPr lang="en-US" sz="1600" spc="-1" dirty="0">
-                <a:solidFill>
-                  <a:srgbClr val="000000"/>
-                </a:solidFill>
-                <a:latin typeface="Century Gothic"/>
-              </a:rPr>
-              <a:t>? </a:t>
-            </a:r>
-          </a:p>
-          <a:p>
-            <a:pPr lvl="1">
-              <a:lnSpc>
-                <a:spcPct val="100000"/>
-              </a:lnSpc>
-              <a:spcBef>
-                <a:spcPts val="400"/>
-              </a:spcBef>
-              <a:buClr>
-                <a:srgbClr val="0064C8"/>
-              </a:buClr>
-              <a:buFont typeface="Wingdings" panose="05000000000000000000" pitchFamily="2" charset="2"/>
-              <a:buChar char="§"/>
-            </a:pPr>
-            <a:endParaRPr lang="en-US" sz="1600" spc="-1" dirty="0">
-              <a:solidFill>
-                <a:srgbClr val="000000"/>
-              </a:solidFill>
-              <a:latin typeface="Century Gothic"/>
-            </a:endParaRPr>
-          </a:p>
-          <a:p>
-            <a:pPr lvl="1">
-              <a:lnSpc>
-                <a:spcPct val="100000"/>
-              </a:lnSpc>
-              <a:spcBef>
-                <a:spcPts val="400"/>
-              </a:spcBef>
-              <a:buClr>
-                <a:srgbClr val="0064C8"/>
-              </a:buClr>
-              <a:buFont typeface="Wingdings" panose="05000000000000000000" pitchFamily="2" charset="2"/>
-              <a:buChar char="§"/>
-            </a:pPr>
-            <a:endParaRPr lang="en-US" sz="1600" spc="-1" dirty="0">
-              <a:solidFill>
-                <a:srgbClr val="000000"/>
-              </a:solidFill>
-              <a:latin typeface="Century Gothic"/>
-            </a:endParaRPr>
           </a:p>
           <a:p>
             <a:pPr>
@@ -10569,7 +10968,1186 @@
     </p:spTree>
     <p:extLst>
       <p:ext uri="{BB962C8B-B14F-4D97-AF65-F5344CB8AC3E}">
+        <p14:creationId xmlns:p14="http://schemas.microsoft.com/office/powerpoint/2010/main" val="3727029337"/>
+      </p:ext>
+    </p:extLst>
+  </p:cSld>
+  <p:clrMapOvr>
+    <a:masterClrMapping/>
+  </p:clrMapOvr>
+</p:sld>
+</file>
+
+<file path=ppt/slides/slide12.xml><?xml version="1.0" encoding="utf-8"?>
+<p:sld xmlns:a="http://schemas.openxmlformats.org/drawingml/2006/main" xmlns:r="http://schemas.openxmlformats.org/officeDocument/2006/relationships" xmlns:p="http://schemas.openxmlformats.org/presentationml/2006/main">
+  <p:cSld>
+    <p:spTree>
+      <p:nvGrpSpPr>
+        <p:cNvPr id="1" name="">
+          <a:extLst>
+            <a:ext uri="{FF2B5EF4-FFF2-40B4-BE49-F238E27FC236}">
+              <a16:creationId xmlns:a16="http://schemas.microsoft.com/office/drawing/2014/main" id="{A6515F23-0912-A838-23CE-B8F00573A2DA}"/>
+            </a:ext>
+          </a:extLst>
+        </p:cNvPr>
+        <p:cNvGrpSpPr/>
+        <p:nvPr/>
+      </p:nvGrpSpPr>
+      <p:grpSpPr>
+        <a:xfrm>
+          <a:off x="0" y="0"/>
+          <a:ext cx="0" cy="0"/>
+          <a:chOff x="0" y="0"/>
+          <a:chExt cx="0" cy="0"/>
+        </a:xfrm>
+      </p:grpSpPr>
+      <p:sp>
+        <p:nvSpPr>
+          <p:cNvPr id="163" name="PlaceHolder 1">
+            <a:extLst>
+              <a:ext uri="{FF2B5EF4-FFF2-40B4-BE49-F238E27FC236}">
+                <a16:creationId xmlns:a16="http://schemas.microsoft.com/office/drawing/2014/main" id="{57944F4B-F502-E7CC-8790-8737702BC6AC}"/>
+              </a:ext>
+            </a:extLst>
+          </p:cNvPr>
+          <p:cNvSpPr>
+            <a:spLocks noGrp="1"/>
+          </p:cNvSpPr>
+          <p:nvPr>
+            <p:ph type="title"/>
+          </p:nvPr>
+        </p:nvSpPr>
+        <p:spPr>
+          <a:xfrm>
+            <a:off x="380880" y="228600"/>
+            <a:ext cx="8380080" cy="837720"/>
+          </a:xfrm>
+          <a:prstGeom prst="rect">
+            <a:avLst/>
+          </a:prstGeom>
+          <a:noFill/>
+          <a:ln w="0">
+            <a:noFill/>
+          </a:ln>
+        </p:spPr>
+        <p:txBody>
+          <a:bodyPr numCol="1" spcCol="0" anchor="ctr">
+            <a:noAutofit/>
+          </a:bodyPr>
+          <a:lstStyle/>
+          <a:p>
+            <a:pPr>
+              <a:lnSpc>
+                <a:spcPct val="100000"/>
+              </a:lnSpc>
+              <a:buNone/>
+            </a:pPr>
+            <a:r>
+              <a:rPr lang="en-US" sz="3200" b="0" strike="noStrike" spc="-1" dirty="0">
+                <a:solidFill>
+                  <a:srgbClr val="0064C8"/>
+                </a:solidFill>
+                <a:latin typeface="Century Gothic"/>
+              </a:rPr>
+              <a:t>Framing</a:t>
+            </a:r>
+            <a:endParaRPr lang="en-US" sz="3200" b="0" strike="noStrike" spc="-1" dirty="0">
+              <a:solidFill>
+                <a:srgbClr val="000000"/>
+              </a:solidFill>
+              <a:latin typeface="Century Gothic"/>
+            </a:endParaRPr>
+          </a:p>
+        </p:txBody>
+      </p:sp>
+      <p:sp>
+        <p:nvSpPr>
+          <p:cNvPr id="165" name="PlaceHolder 3">
+            <a:extLst>
+              <a:ext uri="{FF2B5EF4-FFF2-40B4-BE49-F238E27FC236}">
+                <a16:creationId xmlns:a16="http://schemas.microsoft.com/office/drawing/2014/main" id="{2EFBEA53-7B78-D9A1-93EF-9608A3193D27}"/>
+              </a:ext>
+            </a:extLst>
+          </p:cNvPr>
+          <p:cNvSpPr>
+            <a:spLocks noGrp="1"/>
+          </p:cNvSpPr>
+          <p:nvPr>
+            <p:ph type="sldNum"/>
+          </p:nvPr>
+        </p:nvSpPr>
+        <p:spPr>
+          <a:xfrm>
+            <a:off x="8376840" y="5692680"/>
+            <a:ext cx="384120" cy="364680"/>
+          </a:xfrm>
+          <a:prstGeom prst="rect">
+            <a:avLst/>
+          </a:prstGeom>
+          <a:noFill/>
+          <a:ln w="0">
+            <a:noFill/>
+          </a:ln>
+        </p:spPr>
+        <p:txBody>
+          <a:bodyPr anchor="ctr">
+            <a:noAutofit/>
+          </a:bodyPr>
+          <a:lstStyle/>
+          <a:p>
+            <a:pPr algn="r">
+              <a:lnSpc>
+                <a:spcPct val="100000"/>
+              </a:lnSpc>
+              <a:buNone/>
+            </a:pPr>
+            <a:fld id="{8BD7C522-1E12-40C3-B25E-5F0462E20B22}" type="slidenum">
+              <a:rPr lang="en-US" sz="1200" b="0" strike="noStrike" spc="-1">
+                <a:solidFill>
+                  <a:srgbClr val="8B8B8B"/>
+                </a:solidFill>
+                <a:latin typeface="Century Gothic"/>
+              </a:rPr>
+              <a:t>12</a:t>
+            </a:fld>
+            <a:endParaRPr lang="en-GB" sz="1200" b="0" strike="noStrike" spc="-1" dirty="0">
+              <a:latin typeface="Times New Roman"/>
+            </a:endParaRPr>
+          </a:p>
+        </p:txBody>
+      </p:sp>
+      <p:sp>
+        <p:nvSpPr>
+          <p:cNvPr id="7" name="PlaceHolder 2">
+            <a:extLst>
+              <a:ext uri="{FF2B5EF4-FFF2-40B4-BE49-F238E27FC236}">
+                <a16:creationId xmlns:a16="http://schemas.microsoft.com/office/drawing/2014/main" id="{66DE14D4-64D4-6D1F-DD92-BC16D674C58B}"/>
+              </a:ext>
+            </a:extLst>
+          </p:cNvPr>
+          <p:cNvSpPr txBox="1">
+            <a:spLocks/>
+          </p:cNvSpPr>
+          <p:nvPr/>
+        </p:nvSpPr>
+        <p:spPr>
+          <a:xfrm>
+            <a:off x="380880" y="1371598"/>
+            <a:ext cx="8109070" cy="4559301"/>
+          </a:xfrm>
+          <a:prstGeom prst="rect">
+            <a:avLst/>
+          </a:prstGeom>
+          <a:noFill/>
+          <a:ln w="0">
+            <a:noFill/>
+          </a:ln>
+        </p:spPr>
+        <p:txBody>
+          <a:bodyPr numCol="1" spcCol="0" anchor="t">
+            <a:noAutofit/>
+          </a:bodyPr>
+          <a:lstStyle>
+            <a:lvl1pPr marL="228600" indent="-228600" algn="l" defTabSz="914400" rtl="0" eaLnBrk="1" latinLnBrk="0" hangingPunct="1">
+              <a:lnSpc>
+                <a:spcPct val="90000"/>
+              </a:lnSpc>
+              <a:spcBef>
+                <a:spcPts val="1000"/>
+              </a:spcBef>
+              <a:buFont typeface="Arial" panose="020B0604020202020204" pitchFamily="34" charset="0"/>
+              <a:buChar char="•"/>
+              <a:defRPr sz="2800" kern="1200">
+                <a:solidFill>
+                  <a:schemeClr val="tx1"/>
+                </a:solidFill>
+                <a:latin typeface="+mn-lt"/>
+                <a:ea typeface="+mn-ea"/>
+                <a:cs typeface="+mn-cs"/>
+              </a:defRPr>
+            </a:lvl1pPr>
+            <a:lvl2pPr marL="685800" indent="-228600" algn="l" defTabSz="914400" rtl="0" eaLnBrk="1" latinLnBrk="0" hangingPunct="1">
+              <a:lnSpc>
+                <a:spcPct val="90000"/>
+              </a:lnSpc>
+              <a:spcBef>
+                <a:spcPts val="500"/>
+              </a:spcBef>
+              <a:buFont typeface="Arial" panose="020B0604020202020204" pitchFamily="34" charset="0"/>
+              <a:buChar char="•"/>
+              <a:defRPr sz="2400" kern="1200">
+                <a:solidFill>
+                  <a:schemeClr val="tx1"/>
+                </a:solidFill>
+                <a:latin typeface="+mn-lt"/>
+                <a:ea typeface="+mn-ea"/>
+                <a:cs typeface="+mn-cs"/>
+              </a:defRPr>
+            </a:lvl2pPr>
+            <a:lvl3pPr marL="1143000" indent="-228600" algn="l" defTabSz="914400" rtl="0" eaLnBrk="1" latinLnBrk="0" hangingPunct="1">
+              <a:lnSpc>
+                <a:spcPct val="90000"/>
+              </a:lnSpc>
+              <a:spcBef>
+                <a:spcPts val="500"/>
+              </a:spcBef>
+              <a:buFont typeface="Arial" panose="020B0604020202020204" pitchFamily="34" charset="0"/>
+              <a:buChar char="•"/>
+              <a:defRPr sz="2000" kern="1200">
+                <a:solidFill>
+                  <a:schemeClr val="tx1"/>
+                </a:solidFill>
+                <a:latin typeface="+mn-lt"/>
+                <a:ea typeface="+mn-ea"/>
+                <a:cs typeface="+mn-cs"/>
+              </a:defRPr>
+            </a:lvl3pPr>
+            <a:lvl4pPr marL="1600200" indent="-228600" algn="l" defTabSz="914400" rtl="0" eaLnBrk="1" latinLnBrk="0" hangingPunct="1">
+              <a:lnSpc>
+                <a:spcPct val="90000"/>
+              </a:lnSpc>
+              <a:spcBef>
+                <a:spcPts val="500"/>
+              </a:spcBef>
+              <a:buFont typeface="Arial" panose="020B0604020202020204" pitchFamily="34" charset="0"/>
+              <a:buChar char="•"/>
+              <a:defRPr sz="1800" kern="1200">
+                <a:solidFill>
+                  <a:schemeClr val="tx1"/>
+                </a:solidFill>
+                <a:latin typeface="+mn-lt"/>
+                <a:ea typeface="+mn-ea"/>
+                <a:cs typeface="+mn-cs"/>
+              </a:defRPr>
+            </a:lvl4pPr>
+            <a:lvl5pPr marL="2057400" indent="-228600" algn="l" defTabSz="914400" rtl="0" eaLnBrk="1" latinLnBrk="0" hangingPunct="1">
+              <a:lnSpc>
+                <a:spcPct val="90000"/>
+              </a:lnSpc>
+              <a:spcBef>
+                <a:spcPts val="500"/>
+              </a:spcBef>
+              <a:buFont typeface="Arial" panose="020B0604020202020204" pitchFamily="34" charset="0"/>
+              <a:buChar char="•"/>
+              <a:defRPr sz="1800" kern="1200">
+                <a:solidFill>
+                  <a:schemeClr val="tx1"/>
+                </a:solidFill>
+                <a:latin typeface="+mn-lt"/>
+                <a:ea typeface="+mn-ea"/>
+                <a:cs typeface="+mn-cs"/>
+              </a:defRPr>
+            </a:lvl5pPr>
+            <a:lvl6pPr marL="2514600" indent="-228600" algn="l" defTabSz="914400" rtl="0" eaLnBrk="1" latinLnBrk="0" hangingPunct="1">
+              <a:lnSpc>
+                <a:spcPct val="90000"/>
+              </a:lnSpc>
+              <a:spcBef>
+                <a:spcPts val="500"/>
+              </a:spcBef>
+              <a:buFont typeface="Arial" panose="020B0604020202020204" pitchFamily="34" charset="0"/>
+              <a:buChar char="•"/>
+              <a:defRPr sz="1800" kern="1200">
+                <a:solidFill>
+                  <a:schemeClr val="tx1"/>
+                </a:solidFill>
+                <a:latin typeface="+mn-lt"/>
+                <a:ea typeface="+mn-ea"/>
+                <a:cs typeface="+mn-cs"/>
+              </a:defRPr>
+            </a:lvl6pPr>
+            <a:lvl7pPr marL="2971800" indent="-228600" algn="l" defTabSz="914400" rtl="0" eaLnBrk="1" latinLnBrk="0" hangingPunct="1">
+              <a:lnSpc>
+                <a:spcPct val="90000"/>
+              </a:lnSpc>
+              <a:spcBef>
+                <a:spcPts val="500"/>
+              </a:spcBef>
+              <a:buFont typeface="Arial" panose="020B0604020202020204" pitchFamily="34" charset="0"/>
+              <a:buChar char="•"/>
+              <a:defRPr sz="1800" kern="1200">
+                <a:solidFill>
+                  <a:schemeClr val="tx1"/>
+                </a:solidFill>
+                <a:latin typeface="+mn-lt"/>
+                <a:ea typeface="+mn-ea"/>
+                <a:cs typeface="+mn-cs"/>
+              </a:defRPr>
+            </a:lvl7pPr>
+            <a:lvl8pPr marL="3429000" indent="-228600" algn="l" defTabSz="914400" rtl="0" eaLnBrk="1" latinLnBrk="0" hangingPunct="1">
+              <a:lnSpc>
+                <a:spcPct val="90000"/>
+              </a:lnSpc>
+              <a:spcBef>
+                <a:spcPts val="500"/>
+              </a:spcBef>
+              <a:buFont typeface="Arial" panose="020B0604020202020204" pitchFamily="34" charset="0"/>
+              <a:buChar char="•"/>
+              <a:defRPr sz="1800" kern="1200">
+                <a:solidFill>
+                  <a:schemeClr val="tx1"/>
+                </a:solidFill>
+                <a:latin typeface="+mn-lt"/>
+                <a:ea typeface="+mn-ea"/>
+                <a:cs typeface="+mn-cs"/>
+              </a:defRPr>
+            </a:lvl8pPr>
+            <a:lvl9pPr marL="3886200" indent="-228600" algn="l" defTabSz="914400" rtl="0" eaLnBrk="1" latinLnBrk="0" hangingPunct="1">
+              <a:lnSpc>
+                <a:spcPct val="90000"/>
+              </a:lnSpc>
+              <a:spcBef>
+                <a:spcPts val="500"/>
+              </a:spcBef>
+              <a:buFont typeface="Arial" panose="020B0604020202020204" pitchFamily="34" charset="0"/>
+              <a:buChar char="•"/>
+              <a:defRPr sz="1800" kern="1200">
+                <a:solidFill>
+                  <a:schemeClr val="tx1"/>
+                </a:solidFill>
+                <a:latin typeface="+mn-lt"/>
+                <a:ea typeface="+mn-ea"/>
+                <a:cs typeface="+mn-cs"/>
+              </a:defRPr>
+            </a:lvl9pPr>
+          </a:lstStyle>
+          <a:p>
+            <a:pPr>
+              <a:lnSpc>
+                <a:spcPct val="100000"/>
+              </a:lnSpc>
+              <a:spcBef>
+                <a:spcPts val="400"/>
+              </a:spcBef>
+              <a:buClr>
+                <a:srgbClr val="0064C8"/>
+              </a:buClr>
+              <a:buFont typeface="Wingdings" panose="05000000000000000000" pitchFamily="2" charset="2"/>
+              <a:buChar char="§"/>
+            </a:pPr>
+            <a:r>
+              <a:rPr lang="en-US" sz="2000" spc="-1" dirty="0">
+                <a:solidFill>
+                  <a:srgbClr val="000000"/>
+                </a:solidFill>
+                <a:latin typeface="Century Gothic"/>
+              </a:rPr>
+              <a:t>How to frame the project:</a:t>
+            </a:r>
+          </a:p>
+          <a:p>
+            <a:pPr lvl="1">
+              <a:lnSpc>
+                <a:spcPct val="100000"/>
+              </a:lnSpc>
+              <a:spcBef>
+                <a:spcPts val="400"/>
+              </a:spcBef>
+              <a:buClr>
+                <a:srgbClr val="0064C8"/>
+              </a:buClr>
+              <a:buFont typeface="Wingdings" panose="05000000000000000000" pitchFamily="2" charset="2"/>
+              <a:buChar char="§"/>
+            </a:pPr>
+            <a:r>
+              <a:rPr lang="en-US" sz="1600" spc="-1" dirty="0">
+                <a:solidFill>
+                  <a:srgbClr val="000000"/>
+                </a:solidFill>
+                <a:latin typeface="Century Gothic"/>
+              </a:rPr>
+              <a:t>A proof-of-concept study?</a:t>
+            </a:r>
+          </a:p>
+          <a:p>
+            <a:pPr lvl="1">
+              <a:lnSpc>
+                <a:spcPct val="100000"/>
+              </a:lnSpc>
+              <a:spcBef>
+                <a:spcPts val="400"/>
+              </a:spcBef>
+              <a:buClr>
+                <a:srgbClr val="0064C8"/>
+              </a:buClr>
+              <a:buFont typeface="Wingdings" panose="05000000000000000000" pitchFamily="2" charset="2"/>
+              <a:buChar char="§"/>
+            </a:pPr>
+            <a:r>
+              <a:rPr lang="en-US" sz="1600" spc="-1" dirty="0">
+                <a:solidFill>
+                  <a:srgbClr val="000000"/>
+                </a:solidFill>
+                <a:latin typeface="Century Gothic"/>
+              </a:rPr>
+              <a:t>An explainability platform for XAI applied to molecular design?</a:t>
+            </a:r>
+          </a:p>
+          <a:p>
+            <a:pPr lvl="1">
+              <a:lnSpc>
+                <a:spcPct val="100000"/>
+              </a:lnSpc>
+              <a:spcBef>
+                <a:spcPts val="400"/>
+              </a:spcBef>
+              <a:buClr>
+                <a:srgbClr val="0064C8"/>
+              </a:buClr>
+              <a:buFont typeface="Wingdings" panose="05000000000000000000" pitchFamily="2" charset="2"/>
+              <a:buChar char="§"/>
+            </a:pPr>
+            <a:r>
+              <a:rPr lang="en-US" sz="1600" spc="-1" dirty="0">
+                <a:solidFill>
+                  <a:srgbClr val="000000"/>
+                </a:solidFill>
+                <a:latin typeface="Century Gothic"/>
+              </a:rPr>
+              <a:t>An explainability platform for XAI specific to molecular selectivity?</a:t>
+            </a:r>
+          </a:p>
+          <a:p>
+            <a:pPr lvl="1">
+              <a:lnSpc>
+                <a:spcPct val="100000"/>
+              </a:lnSpc>
+              <a:spcBef>
+                <a:spcPts val="400"/>
+              </a:spcBef>
+              <a:buClr>
+                <a:srgbClr val="0064C8"/>
+              </a:buClr>
+              <a:buFont typeface="Wingdings" panose="05000000000000000000" pitchFamily="2" charset="2"/>
+              <a:buChar char="§"/>
+            </a:pPr>
+            <a:r>
+              <a:rPr lang="en-US" sz="1600" spc="-1" dirty="0">
+                <a:solidFill>
+                  <a:srgbClr val="000000"/>
+                </a:solidFill>
+                <a:latin typeface="Century Gothic"/>
+              </a:rPr>
+              <a:t>A modular </a:t>
+            </a:r>
+            <a:r>
+              <a:rPr lang="en-US" sz="1600" spc="-1" dirty="0" err="1">
+                <a:solidFill>
+                  <a:srgbClr val="000000"/>
+                </a:solidFill>
+                <a:latin typeface="Century Gothic"/>
+              </a:rPr>
+              <a:t>explainability</a:t>
+            </a:r>
+            <a:r>
+              <a:rPr lang="en-US" sz="1600" spc="-1" dirty="0">
+                <a:solidFill>
+                  <a:srgbClr val="000000"/>
+                </a:solidFill>
+                <a:latin typeface="Century Gothic"/>
+              </a:rPr>
+              <a:t>-enhanced platform for </a:t>
+            </a:r>
+            <a:r>
+              <a:rPr lang="en-US" sz="1600" spc="-1" dirty="0" err="1">
+                <a:solidFill>
+                  <a:srgbClr val="000000"/>
+                </a:solidFill>
+                <a:latin typeface="Century Gothic"/>
+              </a:rPr>
+              <a:t>chemoinformatics</a:t>
+            </a:r>
+            <a:r>
+              <a:rPr lang="en-US" sz="1600" spc="-1" dirty="0">
+                <a:solidFill>
+                  <a:srgbClr val="000000"/>
+                </a:solidFill>
+                <a:latin typeface="Century Gothic"/>
+              </a:rPr>
+              <a:t>? </a:t>
+            </a:r>
+          </a:p>
+          <a:p>
+            <a:pPr lvl="1">
+              <a:lnSpc>
+                <a:spcPct val="100000"/>
+              </a:lnSpc>
+              <a:spcBef>
+                <a:spcPts val="400"/>
+              </a:spcBef>
+              <a:buClr>
+                <a:srgbClr val="0064C8"/>
+              </a:buClr>
+              <a:buFont typeface="Wingdings" panose="05000000000000000000" pitchFamily="2" charset="2"/>
+              <a:buChar char="§"/>
+            </a:pPr>
+            <a:endParaRPr lang="en-US" sz="1600" spc="-1" dirty="0">
+              <a:solidFill>
+                <a:srgbClr val="000000"/>
+              </a:solidFill>
+              <a:latin typeface="Century Gothic"/>
+            </a:endParaRPr>
+          </a:p>
+          <a:p>
+            <a:pPr lvl="1">
+              <a:lnSpc>
+                <a:spcPct val="100000"/>
+              </a:lnSpc>
+              <a:spcBef>
+                <a:spcPts val="400"/>
+              </a:spcBef>
+              <a:buClr>
+                <a:srgbClr val="0064C8"/>
+              </a:buClr>
+              <a:buFont typeface="Wingdings" panose="05000000000000000000" pitchFamily="2" charset="2"/>
+              <a:buChar char="§"/>
+            </a:pPr>
+            <a:endParaRPr lang="en-US" sz="1600" spc="-1" dirty="0">
+              <a:solidFill>
+                <a:srgbClr val="000000"/>
+              </a:solidFill>
+              <a:latin typeface="Century Gothic"/>
+            </a:endParaRPr>
+          </a:p>
+          <a:p>
+            <a:pPr>
+              <a:lnSpc>
+                <a:spcPct val="100000"/>
+              </a:lnSpc>
+              <a:spcBef>
+                <a:spcPts val="400"/>
+              </a:spcBef>
+              <a:buClr>
+                <a:srgbClr val="0064C8"/>
+              </a:buClr>
+              <a:buFont typeface="Wingdings" panose="05000000000000000000" pitchFamily="2" charset="2"/>
+              <a:buChar char="§"/>
+            </a:pPr>
+            <a:endParaRPr lang="en-US" sz="2000" spc="-1" dirty="0">
+              <a:solidFill>
+                <a:srgbClr val="000000"/>
+              </a:solidFill>
+              <a:latin typeface="Century Gothic"/>
+            </a:endParaRPr>
+          </a:p>
+          <a:p>
+            <a:pPr>
+              <a:lnSpc>
+                <a:spcPct val="100000"/>
+              </a:lnSpc>
+              <a:spcBef>
+                <a:spcPts val="400"/>
+              </a:spcBef>
+              <a:buClr>
+                <a:srgbClr val="0064C8"/>
+              </a:buClr>
+              <a:buFont typeface="Wingdings" panose="05000000000000000000" pitchFamily="2" charset="2"/>
+              <a:buChar char="§"/>
+            </a:pPr>
+            <a:endParaRPr lang="en-US" sz="1800" spc="-1" dirty="0">
+              <a:solidFill>
+                <a:srgbClr val="000000"/>
+              </a:solidFill>
+              <a:latin typeface="Century Gothic"/>
+            </a:endParaRPr>
+          </a:p>
+          <a:p>
+            <a:pPr marL="343080" indent="-343080">
+              <a:lnSpc>
+                <a:spcPct val="100000"/>
+              </a:lnSpc>
+              <a:spcBef>
+                <a:spcPts val="400"/>
+              </a:spcBef>
+              <a:spcAft>
+                <a:spcPts val="601"/>
+              </a:spcAft>
+              <a:buClr>
+                <a:srgbClr val="0064C8"/>
+              </a:buClr>
+              <a:buFont typeface="Wingdings 2" charset="2"/>
+              <a:buChar char=""/>
+            </a:pPr>
+            <a:endParaRPr lang="en-US" sz="2000" b="1" spc="-1" dirty="0">
+              <a:solidFill>
+                <a:srgbClr val="000000"/>
+              </a:solidFill>
+              <a:latin typeface="Century Gothic"/>
+            </a:endParaRPr>
+          </a:p>
+        </p:txBody>
+      </p:sp>
+    </p:spTree>
+    <p:extLst>
+      <p:ext uri="{BB962C8B-B14F-4D97-AF65-F5344CB8AC3E}">
         <p14:creationId xmlns:p14="http://schemas.microsoft.com/office/powerpoint/2010/main" val="1594879052"/>
+      </p:ext>
+    </p:extLst>
+  </p:cSld>
+  <p:clrMapOvr>
+    <a:masterClrMapping/>
+  </p:clrMapOvr>
+</p:sld>
+</file>
+
+<file path=ppt/slides/slide13.xml><?xml version="1.0" encoding="utf-8"?>
+<p:sld xmlns:a="http://schemas.openxmlformats.org/drawingml/2006/main" xmlns:r="http://schemas.openxmlformats.org/officeDocument/2006/relationships" xmlns:p="http://schemas.openxmlformats.org/presentationml/2006/main" show="0">
+  <p:cSld>
+    <p:spTree>
+      <p:nvGrpSpPr>
+        <p:cNvPr id="1" name="">
+          <a:extLst>
+            <a:ext uri="{FF2B5EF4-FFF2-40B4-BE49-F238E27FC236}">
+              <a16:creationId xmlns:a16="http://schemas.microsoft.com/office/drawing/2014/main" id="{A6515F23-0912-A838-23CE-B8F00573A2DA}"/>
+            </a:ext>
+          </a:extLst>
+        </p:cNvPr>
+        <p:cNvGrpSpPr/>
+        <p:nvPr/>
+      </p:nvGrpSpPr>
+      <p:grpSpPr>
+        <a:xfrm>
+          <a:off x="0" y="0"/>
+          <a:ext cx="0" cy="0"/>
+          <a:chOff x="0" y="0"/>
+          <a:chExt cx="0" cy="0"/>
+        </a:xfrm>
+      </p:grpSpPr>
+      <p:sp>
+        <p:nvSpPr>
+          <p:cNvPr id="163" name="PlaceHolder 1">
+            <a:extLst>
+              <a:ext uri="{FF2B5EF4-FFF2-40B4-BE49-F238E27FC236}">
+                <a16:creationId xmlns:a16="http://schemas.microsoft.com/office/drawing/2014/main" id="{57944F4B-F502-E7CC-8790-8737702BC6AC}"/>
+              </a:ext>
+            </a:extLst>
+          </p:cNvPr>
+          <p:cNvSpPr>
+            <a:spLocks noGrp="1"/>
+          </p:cNvSpPr>
+          <p:nvPr>
+            <p:ph type="title"/>
+          </p:nvPr>
+        </p:nvSpPr>
+        <p:spPr>
+          <a:xfrm>
+            <a:off x="380880" y="228600"/>
+            <a:ext cx="8380080" cy="837720"/>
+          </a:xfrm>
+          <a:prstGeom prst="rect">
+            <a:avLst/>
+          </a:prstGeom>
+          <a:noFill/>
+          <a:ln w="0">
+            <a:noFill/>
+          </a:ln>
+        </p:spPr>
+        <p:txBody>
+          <a:bodyPr numCol="1" spcCol="0" anchor="ctr">
+            <a:noAutofit/>
+          </a:bodyPr>
+          <a:lstStyle/>
+          <a:p>
+            <a:pPr>
+              <a:lnSpc>
+                <a:spcPct val="100000"/>
+              </a:lnSpc>
+              <a:buNone/>
+            </a:pPr>
+            <a:r>
+              <a:rPr lang="en-US" sz="3200" b="0" strike="noStrike" spc="-1" dirty="0">
+                <a:solidFill>
+                  <a:srgbClr val="0064C8"/>
+                </a:solidFill>
+                <a:latin typeface="Century Gothic"/>
+              </a:rPr>
+              <a:t>Exemplary answer output</a:t>
+            </a:r>
+            <a:endParaRPr lang="en-US" sz="3200" b="0" strike="noStrike" spc="-1" dirty="0">
+              <a:solidFill>
+                <a:srgbClr val="000000"/>
+              </a:solidFill>
+              <a:latin typeface="Century Gothic"/>
+            </a:endParaRPr>
+          </a:p>
+        </p:txBody>
+      </p:sp>
+      <p:sp>
+        <p:nvSpPr>
+          <p:cNvPr id="165" name="PlaceHolder 3">
+            <a:extLst>
+              <a:ext uri="{FF2B5EF4-FFF2-40B4-BE49-F238E27FC236}">
+                <a16:creationId xmlns:a16="http://schemas.microsoft.com/office/drawing/2014/main" id="{2EFBEA53-7B78-D9A1-93EF-9608A3193D27}"/>
+              </a:ext>
+            </a:extLst>
+          </p:cNvPr>
+          <p:cNvSpPr>
+            <a:spLocks noGrp="1"/>
+          </p:cNvSpPr>
+          <p:nvPr>
+            <p:ph type="sldNum"/>
+          </p:nvPr>
+        </p:nvSpPr>
+        <p:spPr>
+          <a:xfrm>
+            <a:off x="8376840" y="5692680"/>
+            <a:ext cx="384120" cy="364680"/>
+          </a:xfrm>
+          <a:prstGeom prst="rect">
+            <a:avLst/>
+          </a:prstGeom>
+          <a:noFill/>
+          <a:ln w="0">
+            <a:noFill/>
+          </a:ln>
+        </p:spPr>
+        <p:txBody>
+          <a:bodyPr anchor="ctr">
+            <a:noAutofit/>
+          </a:bodyPr>
+          <a:lstStyle/>
+          <a:p>
+            <a:pPr algn="r">
+              <a:lnSpc>
+                <a:spcPct val="100000"/>
+              </a:lnSpc>
+              <a:buNone/>
+            </a:pPr>
+            <a:fld id="{8BD7C522-1E12-40C3-B25E-5F0462E20B22}" type="slidenum">
+              <a:rPr lang="en-US" sz="1200" b="0" strike="noStrike" spc="-1">
+                <a:solidFill>
+                  <a:srgbClr val="8B8B8B"/>
+                </a:solidFill>
+                <a:latin typeface="Century Gothic"/>
+              </a:rPr>
+              <a:t>13</a:t>
+            </a:fld>
+            <a:endParaRPr lang="en-GB" sz="1200" b="0" strike="noStrike" spc="-1" dirty="0">
+              <a:latin typeface="Times New Roman"/>
+            </a:endParaRPr>
+          </a:p>
+        </p:txBody>
+      </p:sp>
+      <p:sp>
+        <p:nvSpPr>
+          <p:cNvPr id="2" name="PlaceHolder 2">
+            <a:extLst>
+              <a:ext uri="{FF2B5EF4-FFF2-40B4-BE49-F238E27FC236}">
+                <a16:creationId xmlns:a16="http://schemas.microsoft.com/office/drawing/2014/main" id="{870990D0-7AC5-46BA-6FC4-274F8E0A3ABE}"/>
+              </a:ext>
+            </a:extLst>
+          </p:cNvPr>
+          <p:cNvSpPr txBox="1">
+            <a:spLocks/>
+          </p:cNvSpPr>
+          <p:nvPr/>
+        </p:nvSpPr>
+        <p:spPr>
+          <a:xfrm>
+            <a:off x="380880" y="1371598"/>
+            <a:ext cx="3306353" cy="4559301"/>
+          </a:xfrm>
+          <a:prstGeom prst="rect">
+            <a:avLst/>
+          </a:prstGeom>
+          <a:noFill/>
+          <a:ln w="0">
+            <a:noFill/>
+          </a:ln>
+        </p:spPr>
+        <p:txBody>
+          <a:bodyPr numCol="1" spcCol="0" anchor="t">
+            <a:noAutofit/>
+          </a:bodyPr>
+          <a:lstStyle>
+            <a:lvl1pPr marL="228600" indent="-228600" algn="l" defTabSz="914400" rtl="0" eaLnBrk="1" latinLnBrk="0" hangingPunct="1">
+              <a:lnSpc>
+                <a:spcPct val="90000"/>
+              </a:lnSpc>
+              <a:spcBef>
+                <a:spcPts val="1000"/>
+              </a:spcBef>
+              <a:buFont typeface="Arial" panose="020B0604020202020204" pitchFamily="34" charset="0"/>
+              <a:buChar char="•"/>
+              <a:defRPr sz="2800" kern="1200">
+                <a:solidFill>
+                  <a:schemeClr val="tx1"/>
+                </a:solidFill>
+                <a:latin typeface="+mn-lt"/>
+                <a:ea typeface="+mn-ea"/>
+                <a:cs typeface="+mn-cs"/>
+              </a:defRPr>
+            </a:lvl1pPr>
+            <a:lvl2pPr marL="685800" indent="-228600" algn="l" defTabSz="914400" rtl="0" eaLnBrk="1" latinLnBrk="0" hangingPunct="1">
+              <a:lnSpc>
+                <a:spcPct val="90000"/>
+              </a:lnSpc>
+              <a:spcBef>
+                <a:spcPts val="500"/>
+              </a:spcBef>
+              <a:buFont typeface="Arial" panose="020B0604020202020204" pitchFamily="34" charset="0"/>
+              <a:buChar char="•"/>
+              <a:defRPr sz="2400" kern="1200">
+                <a:solidFill>
+                  <a:schemeClr val="tx1"/>
+                </a:solidFill>
+                <a:latin typeface="+mn-lt"/>
+                <a:ea typeface="+mn-ea"/>
+                <a:cs typeface="+mn-cs"/>
+              </a:defRPr>
+            </a:lvl2pPr>
+            <a:lvl3pPr marL="1143000" indent="-228600" algn="l" defTabSz="914400" rtl="0" eaLnBrk="1" latinLnBrk="0" hangingPunct="1">
+              <a:lnSpc>
+                <a:spcPct val="90000"/>
+              </a:lnSpc>
+              <a:spcBef>
+                <a:spcPts val="500"/>
+              </a:spcBef>
+              <a:buFont typeface="Arial" panose="020B0604020202020204" pitchFamily="34" charset="0"/>
+              <a:buChar char="•"/>
+              <a:defRPr sz="2000" kern="1200">
+                <a:solidFill>
+                  <a:schemeClr val="tx1"/>
+                </a:solidFill>
+                <a:latin typeface="+mn-lt"/>
+                <a:ea typeface="+mn-ea"/>
+                <a:cs typeface="+mn-cs"/>
+              </a:defRPr>
+            </a:lvl3pPr>
+            <a:lvl4pPr marL="1600200" indent="-228600" algn="l" defTabSz="914400" rtl="0" eaLnBrk="1" latinLnBrk="0" hangingPunct="1">
+              <a:lnSpc>
+                <a:spcPct val="90000"/>
+              </a:lnSpc>
+              <a:spcBef>
+                <a:spcPts val="500"/>
+              </a:spcBef>
+              <a:buFont typeface="Arial" panose="020B0604020202020204" pitchFamily="34" charset="0"/>
+              <a:buChar char="•"/>
+              <a:defRPr sz="1800" kern="1200">
+                <a:solidFill>
+                  <a:schemeClr val="tx1"/>
+                </a:solidFill>
+                <a:latin typeface="+mn-lt"/>
+                <a:ea typeface="+mn-ea"/>
+                <a:cs typeface="+mn-cs"/>
+              </a:defRPr>
+            </a:lvl4pPr>
+            <a:lvl5pPr marL="2057400" indent="-228600" algn="l" defTabSz="914400" rtl="0" eaLnBrk="1" latinLnBrk="0" hangingPunct="1">
+              <a:lnSpc>
+                <a:spcPct val="90000"/>
+              </a:lnSpc>
+              <a:spcBef>
+                <a:spcPts val="500"/>
+              </a:spcBef>
+              <a:buFont typeface="Arial" panose="020B0604020202020204" pitchFamily="34" charset="0"/>
+              <a:buChar char="•"/>
+              <a:defRPr sz="1800" kern="1200">
+                <a:solidFill>
+                  <a:schemeClr val="tx1"/>
+                </a:solidFill>
+                <a:latin typeface="+mn-lt"/>
+                <a:ea typeface="+mn-ea"/>
+                <a:cs typeface="+mn-cs"/>
+              </a:defRPr>
+            </a:lvl5pPr>
+            <a:lvl6pPr marL="2514600" indent="-228600" algn="l" defTabSz="914400" rtl="0" eaLnBrk="1" latinLnBrk="0" hangingPunct="1">
+              <a:lnSpc>
+                <a:spcPct val="90000"/>
+              </a:lnSpc>
+              <a:spcBef>
+                <a:spcPts val="500"/>
+              </a:spcBef>
+              <a:buFont typeface="Arial" panose="020B0604020202020204" pitchFamily="34" charset="0"/>
+              <a:buChar char="•"/>
+              <a:defRPr sz="1800" kern="1200">
+                <a:solidFill>
+                  <a:schemeClr val="tx1"/>
+                </a:solidFill>
+                <a:latin typeface="+mn-lt"/>
+                <a:ea typeface="+mn-ea"/>
+                <a:cs typeface="+mn-cs"/>
+              </a:defRPr>
+            </a:lvl6pPr>
+            <a:lvl7pPr marL="2971800" indent="-228600" algn="l" defTabSz="914400" rtl="0" eaLnBrk="1" latinLnBrk="0" hangingPunct="1">
+              <a:lnSpc>
+                <a:spcPct val="90000"/>
+              </a:lnSpc>
+              <a:spcBef>
+                <a:spcPts val="500"/>
+              </a:spcBef>
+              <a:buFont typeface="Arial" panose="020B0604020202020204" pitchFamily="34" charset="0"/>
+              <a:buChar char="•"/>
+              <a:defRPr sz="1800" kern="1200">
+                <a:solidFill>
+                  <a:schemeClr val="tx1"/>
+                </a:solidFill>
+                <a:latin typeface="+mn-lt"/>
+                <a:ea typeface="+mn-ea"/>
+                <a:cs typeface="+mn-cs"/>
+              </a:defRPr>
+            </a:lvl7pPr>
+            <a:lvl8pPr marL="3429000" indent="-228600" algn="l" defTabSz="914400" rtl="0" eaLnBrk="1" latinLnBrk="0" hangingPunct="1">
+              <a:lnSpc>
+                <a:spcPct val="90000"/>
+              </a:lnSpc>
+              <a:spcBef>
+                <a:spcPts val="500"/>
+              </a:spcBef>
+              <a:buFont typeface="Arial" panose="020B0604020202020204" pitchFamily="34" charset="0"/>
+              <a:buChar char="•"/>
+              <a:defRPr sz="1800" kern="1200">
+                <a:solidFill>
+                  <a:schemeClr val="tx1"/>
+                </a:solidFill>
+                <a:latin typeface="+mn-lt"/>
+                <a:ea typeface="+mn-ea"/>
+                <a:cs typeface="+mn-cs"/>
+              </a:defRPr>
+            </a:lvl8pPr>
+            <a:lvl9pPr marL="3886200" indent="-228600" algn="l" defTabSz="914400" rtl="0" eaLnBrk="1" latinLnBrk="0" hangingPunct="1">
+              <a:lnSpc>
+                <a:spcPct val="90000"/>
+              </a:lnSpc>
+              <a:spcBef>
+                <a:spcPts val="500"/>
+              </a:spcBef>
+              <a:buFont typeface="Arial" panose="020B0604020202020204" pitchFamily="34" charset="0"/>
+              <a:buChar char="•"/>
+              <a:defRPr sz="1800" kern="1200">
+                <a:solidFill>
+                  <a:schemeClr val="tx1"/>
+                </a:solidFill>
+                <a:latin typeface="+mn-lt"/>
+                <a:ea typeface="+mn-ea"/>
+                <a:cs typeface="+mn-cs"/>
+              </a:defRPr>
+            </a:lvl9pPr>
+          </a:lstStyle>
+          <a:p>
+            <a:pPr>
+              <a:lnSpc>
+                <a:spcPct val="100000"/>
+              </a:lnSpc>
+              <a:spcBef>
+                <a:spcPts val="400"/>
+              </a:spcBef>
+              <a:buClr>
+                <a:srgbClr val="0064C8"/>
+              </a:buClr>
+              <a:buFont typeface="Wingdings" panose="05000000000000000000" pitchFamily="2" charset="2"/>
+              <a:buChar char="§"/>
+            </a:pPr>
+            <a:r>
+              <a:rPr lang="en-US" sz="2000" spc="-1" dirty="0">
+                <a:solidFill>
+                  <a:srgbClr val="000000"/>
+                </a:solidFill>
+                <a:latin typeface="Century Gothic"/>
+              </a:rPr>
+              <a:t>Build an ML model for a given dataset</a:t>
+            </a:r>
+          </a:p>
+          <a:p>
+            <a:pPr>
+              <a:lnSpc>
+                <a:spcPct val="100000"/>
+              </a:lnSpc>
+              <a:spcBef>
+                <a:spcPts val="400"/>
+              </a:spcBef>
+              <a:buClr>
+                <a:srgbClr val="0064C8"/>
+              </a:buClr>
+              <a:buFont typeface="Wingdings" panose="05000000000000000000" pitchFamily="2" charset="2"/>
+              <a:buChar char="§"/>
+            </a:pPr>
+            <a:endParaRPr lang="en-US" sz="2000" spc="-1" dirty="0">
+              <a:solidFill>
+                <a:srgbClr val="000000"/>
+              </a:solidFill>
+              <a:latin typeface="Century Gothic"/>
+            </a:endParaRPr>
+          </a:p>
+          <a:p>
+            <a:pPr>
+              <a:lnSpc>
+                <a:spcPct val="100000"/>
+              </a:lnSpc>
+              <a:spcBef>
+                <a:spcPts val="400"/>
+              </a:spcBef>
+              <a:buClr>
+                <a:srgbClr val="0064C8"/>
+              </a:buClr>
+              <a:buFont typeface="Wingdings" panose="05000000000000000000" pitchFamily="2" charset="2"/>
+              <a:buChar char="§"/>
+            </a:pPr>
+            <a:r>
+              <a:rPr lang="en-US" sz="2000" spc="-1" dirty="0">
+                <a:solidFill>
+                  <a:srgbClr val="000000"/>
+                </a:solidFill>
+                <a:latin typeface="Century Gothic"/>
+              </a:rPr>
+              <a:t>Get a complete report</a:t>
+            </a:r>
+          </a:p>
+          <a:p>
+            <a:pPr lvl="1">
+              <a:lnSpc>
+                <a:spcPct val="100000"/>
+              </a:lnSpc>
+              <a:spcBef>
+                <a:spcPts val="400"/>
+              </a:spcBef>
+              <a:buClr>
+                <a:srgbClr val="0064C8"/>
+              </a:buClr>
+              <a:buFont typeface="Symbol" panose="05050102010706020507" pitchFamily="18" charset="2"/>
+              <a:buChar char="-"/>
+            </a:pPr>
+            <a:r>
+              <a:rPr lang="en-US" sz="1800" spc="-1" dirty="0">
+                <a:solidFill>
+                  <a:srgbClr val="000000"/>
+                </a:solidFill>
+                <a:latin typeface="Century Gothic"/>
+              </a:rPr>
+              <a:t>Dataset summary</a:t>
+            </a:r>
+          </a:p>
+          <a:p>
+            <a:pPr lvl="1">
+              <a:lnSpc>
+                <a:spcPct val="100000"/>
+              </a:lnSpc>
+              <a:spcBef>
+                <a:spcPts val="400"/>
+              </a:spcBef>
+              <a:buClr>
+                <a:srgbClr val="0064C8"/>
+              </a:buClr>
+              <a:buFont typeface="Symbol" panose="05050102010706020507" pitchFamily="18" charset="2"/>
+              <a:buChar char="-"/>
+            </a:pPr>
+            <a:r>
+              <a:rPr lang="en-US" sz="1800" spc="-1" dirty="0">
+                <a:solidFill>
+                  <a:srgbClr val="000000"/>
+                </a:solidFill>
+                <a:latin typeface="Century Gothic"/>
+              </a:rPr>
+              <a:t>Data split statistics</a:t>
+            </a:r>
+          </a:p>
+          <a:p>
+            <a:pPr lvl="1">
+              <a:lnSpc>
+                <a:spcPct val="100000"/>
+              </a:lnSpc>
+              <a:spcBef>
+                <a:spcPts val="400"/>
+              </a:spcBef>
+              <a:buClr>
+                <a:srgbClr val="0064C8"/>
+              </a:buClr>
+              <a:buFont typeface="Symbol" panose="05050102010706020507" pitchFamily="18" charset="2"/>
+              <a:buChar char="-"/>
+            </a:pPr>
+            <a:r>
+              <a:rPr lang="en-US" sz="1800" spc="-1" dirty="0">
+                <a:solidFill>
+                  <a:srgbClr val="000000"/>
+                </a:solidFill>
+                <a:latin typeface="Century Gothic"/>
+              </a:rPr>
+              <a:t>Model training information</a:t>
+            </a:r>
+          </a:p>
+          <a:p>
+            <a:pPr lvl="1">
+              <a:lnSpc>
+                <a:spcPct val="100000"/>
+              </a:lnSpc>
+              <a:spcBef>
+                <a:spcPts val="400"/>
+              </a:spcBef>
+              <a:buClr>
+                <a:srgbClr val="0064C8"/>
+              </a:buClr>
+              <a:buFont typeface="Symbol" panose="05050102010706020507" pitchFamily="18" charset="2"/>
+              <a:buChar char="-"/>
+            </a:pPr>
+            <a:r>
+              <a:rPr lang="en-US" sz="1800" spc="-1" dirty="0">
+                <a:solidFill>
+                  <a:srgbClr val="000000"/>
+                </a:solidFill>
+                <a:latin typeface="Century Gothic"/>
+              </a:rPr>
+              <a:t>Test set performance </a:t>
+            </a:r>
+          </a:p>
+          <a:p>
+            <a:pPr marL="343080" indent="-343080">
+              <a:lnSpc>
+                <a:spcPct val="100000"/>
+              </a:lnSpc>
+              <a:spcBef>
+                <a:spcPts val="400"/>
+              </a:spcBef>
+              <a:spcAft>
+                <a:spcPts val="601"/>
+              </a:spcAft>
+              <a:buClr>
+                <a:srgbClr val="0064C8"/>
+              </a:buClr>
+              <a:buFont typeface="Wingdings 2" charset="2"/>
+              <a:buChar char=""/>
+            </a:pPr>
+            <a:endParaRPr lang="en-US" sz="2000" b="1" spc="-1" dirty="0">
+              <a:solidFill>
+                <a:srgbClr val="000000"/>
+              </a:solidFill>
+              <a:latin typeface="Century Gothic"/>
+            </a:endParaRPr>
+          </a:p>
+        </p:txBody>
+      </p:sp>
+      <p:pic>
+        <p:nvPicPr>
+          <p:cNvPr id="6" name="Picture 5">
+            <a:extLst>
+              <a:ext uri="{FF2B5EF4-FFF2-40B4-BE49-F238E27FC236}">
+                <a16:creationId xmlns:a16="http://schemas.microsoft.com/office/drawing/2014/main" id="{D3BA145D-265C-C0B1-7C0E-2EE32552E491}"/>
+              </a:ext>
+            </a:extLst>
+          </p:cNvPr>
+          <p:cNvPicPr>
+            <a:picLocks noChangeAspect="1"/>
+          </p:cNvPicPr>
+          <p:nvPr/>
+        </p:nvPicPr>
+        <p:blipFill>
+          <a:blip r:embed="rId2"/>
+          <a:stretch>
+            <a:fillRect/>
+          </a:stretch>
+        </p:blipFill>
+        <p:spPr>
+          <a:xfrm>
+            <a:off x="3817354" y="1196437"/>
+            <a:ext cx="4943606" cy="4598149"/>
+          </a:xfrm>
+          <a:prstGeom prst="rect">
+            <a:avLst/>
+          </a:prstGeom>
+        </p:spPr>
+      </p:pic>
+    </p:spTree>
+    <p:extLst>
+      <p:ext uri="{BB962C8B-B14F-4D97-AF65-F5344CB8AC3E}">
+        <p14:creationId xmlns:p14="http://schemas.microsoft.com/office/powerpoint/2010/main" val="2375808848"/>
       </p:ext>
     </p:extLst>
   </p:cSld>
@@ -11391,7 +12969,7 @@
                 </a:solidFill>
                 <a:latin typeface="Century Gothic"/>
               </a:rPr>
-              <a:t> 3.5</a:t>
+              <a:t> 3.6</a:t>
             </a:r>
             <a:r>
               <a:rPr lang="en-US" sz="1600" spc="-1" dirty="0">
@@ -11751,7 +13329,7 @@
         <p:cNvPr id="1" name="">
           <a:extLst>
             <a:ext uri="{FF2B5EF4-FFF2-40B4-BE49-F238E27FC236}">
-              <a16:creationId xmlns:a16="http://schemas.microsoft.com/office/drawing/2014/main" id="{A6515F23-0912-A838-23CE-B8F00573A2DA}"/>
+              <a16:creationId xmlns:a16="http://schemas.microsoft.com/office/drawing/2014/main" id="{C3CB66AB-4C34-335D-C637-6159F7C9EC35}"/>
             </a:ext>
           </a:extLst>
         </p:cNvPr>
@@ -11771,7 +13349,7 @@
           <p:cNvPr id="163" name="PlaceHolder 1">
             <a:extLst>
               <a:ext uri="{FF2B5EF4-FFF2-40B4-BE49-F238E27FC236}">
-                <a16:creationId xmlns:a16="http://schemas.microsoft.com/office/drawing/2014/main" id="{57944F4B-F502-E7CC-8790-8737702BC6AC}"/>
+                <a16:creationId xmlns:a16="http://schemas.microsoft.com/office/drawing/2014/main" id="{F82143BD-207C-0F21-595D-2BC5AB956A76}"/>
               </a:ext>
             </a:extLst>
           </p:cNvPr>
@@ -11808,13 +13386,40 @@
               <a:buNone/>
             </a:pPr>
             <a:r>
-              <a:rPr lang="en-US" sz="3200" b="0" strike="noStrike" spc="-1" dirty="0">
+              <a:rPr lang="pt-PT" sz="3200" b="0" strike="noStrike" spc="-1" dirty="0" err="1">
                 <a:solidFill>
                   <a:srgbClr val="0064C8"/>
                 </a:solidFill>
                 <a:latin typeface="Century Gothic"/>
               </a:rPr>
-              <a:t>Exemplary answer output</a:t>
+              <a:t>Practical</a:t>
+            </a:r>
+            <a:r>
+              <a:rPr lang="pt-PT" sz="3200" b="0" strike="noStrike" spc="-1" dirty="0">
+                <a:solidFill>
+                  <a:srgbClr val="0064C8"/>
+                </a:solidFill>
+                <a:latin typeface="Century Gothic"/>
+              </a:rPr>
+              <a:t> </a:t>
+            </a:r>
+            <a:r>
+              <a:rPr lang="pt-PT" sz="3200" b="0" strike="noStrike" spc="-1" dirty="0" err="1">
+                <a:solidFill>
+                  <a:srgbClr val="0064C8"/>
+                </a:solidFill>
+                <a:latin typeface="Century Gothic"/>
+              </a:rPr>
+              <a:t>Example</a:t>
+            </a:r>
+            <a:r>
+              <a:rPr lang="pt-PT" sz="3200" b="0" strike="noStrike" spc="-1" dirty="0">
+                <a:solidFill>
+                  <a:srgbClr val="0064C8"/>
+                </a:solidFill>
+                <a:latin typeface="Century Gothic"/>
+              </a:rPr>
+              <a:t> - ML</a:t>
             </a:r>
             <a:endParaRPr lang="en-US" sz="3200" b="0" strike="noStrike" spc="-1" dirty="0">
               <a:solidFill>
@@ -11830,7 +13435,7 @@
           <p:cNvPr id="165" name="PlaceHolder 3">
             <a:extLst>
               <a:ext uri="{FF2B5EF4-FFF2-40B4-BE49-F238E27FC236}">
-                <a16:creationId xmlns:a16="http://schemas.microsoft.com/office/drawing/2014/main" id="{2EFBEA53-7B78-D9A1-93EF-9608A3193D27}"/>
+                <a16:creationId xmlns:a16="http://schemas.microsoft.com/office/drawing/2014/main" id="{44B88D20-671C-6A36-AD5A-B00142FEB557}"/>
               </a:ext>
             </a:extLst>
           </p:cNvPr>
@@ -11883,10 +13488,10 @@
       </p:sp>
       <p:sp>
         <p:nvSpPr>
-          <p:cNvPr id="2" name="PlaceHolder 2">
+          <p:cNvPr id="7" name="PlaceHolder 2">
             <a:extLst>
               <a:ext uri="{FF2B5EF4-FFF2-40B4-BE49-F238E27FC236}">
-                <a16:creationId xmlns:a16="http://schemas.microsoft.com/office/drawing/2014/main" id="{870990D0-7AC5-46BA-6FC4-274F8E0A3ABE}"/>
+                <a16:creationId xmlns:a16="http://schemas.microsoft.com/office/drawing/2014/main" id="{CFDAB819-6BAF-B7C7-0B20-F55019CACA6B}"/>
               </a:ext>
             </a:extLst>
           </p:cNvPr>
@@ -11898,7 +13503,7 @@
         <p:spPr>
           <a:xfrm>
             <a:off x="380880" y="1371598"/>
-            <a:ext cx="3306353" cy="4559301"/>
+            <a:ext cx="4190040" cy="4559301"/>
           </a:xfrm>
           <a:prstGeom prst="rect">
             <a:avLst/>
@@ -12077,6 +13682,46 @@
             </a:lvl9pPr>
           </a:lstStyle>
           <a:p>
+            <a:pPr marL="0" indent="0">
+              <a:lnSpc>
+                <a:spcPct val="100000"/>
+              </a:lnSpc>
+              <a:spcBef>
+                <a:spcPts val="400"/>
+              </a:spcBef>
+              <a:buClr>
+                <a:srgbClr val="0064C8"/>
+              </a:buClr>
+              <a:buNone/>
+            </a:pPr>
+            <a:r>
+              <a:rPr lang="en-US" sz="2000" b="1" strike="noStrike" spc="-1" dirty="0">
+                <a:latin typeface="Century Gothic"/>
+              </a:rPr>
+              <a:t>ML prompt</a:t>
+            </a:r>
+          </a:p>
+          <a:p>
+            <a:pPr marL="0" indent="0">
+              <a:lnSpc>
+                <a:spcPct val="100000"/>
+              </a:lnSpc>
+              <a:spcBef>
+                <a:spcPts val="400"/>
+              </a:spcBef>
+              <a:buClr>
+                <a:srgbClr val="0064C8"/>
+              </a:buClr>
+              <a:buNone/>
+            </a:pPr>
+            <a:endParaRPr lang="en-US" sz="2000" spc="-1" dirty="0">
+              <a:solidFill>
+                <a:srgbClr val="000000"/>
+              </a:solidFill>
+              <a:latin typeface="Century Gothic"/>
+            </a:endParaRPr>
+          </a:p>
+          <a:p>
             <a:pPr>
               <a:lnSpc>
                 <a:spcPct val="100000"/>
@@ -12091,13 +13736,13 @@
               <a:buChar char="§"/>
             </a:pPr>
             <a:r>
-              <a:rPr lang="en-US" sz="2000" spc="-1" dirty="0">
+              <a:rPr lang="en-US" sz="1400" spc="-1" dirty="0">
                 <a:solidFill>
                   <a:srgbClr val="000000"/>
                 </a:solidFill>
                 <a:latin typeface="Century Gothic"/>
               </a:rPr>
-              <a:t>Build an ML model for a given dataset</a:t>
+              <a:t>For the given curated dataset ‘kinase_selectivity.csv’</a:t>
             </a:r>
           </a:p>
           <a:p>
@@ -12114,7 +13759,7 @@
               <a:buFont typeface="Wingdings" panose="05000000000000000000" pitchFamily="2" charset="2"/>
               <a:buChar char="§"/>
             </a:pPr>
-            <a:endParaRPr lang="en-US" sz="2000" spc="-1" dirty="0">
+            <a:endParaRPr lang="en-US" sz="1400" spc="-1" dirty="0">
               <a:solidFill>
                 <a:srgbClr val="000000"/>
               </a:solidFill>
@@ -12136,17 +13781,17 @@
               <a:buChar char="§"/>
             </a:pPr>
             <a:r>
-              <a:rPr lang="en-US" sz="2000" spc="-1" dirty="0">
+              <a:rPr lang="en-US" sz="1400" spc="-1" dirty="0">
                 <a:solidFill>
                   <a:srgbClr val="000000"/>
                 </a:solidFill>
                 <a:latin typeface="Century Gothic"/>
               </a:rPr>
-              <a:t>Get a complete report</a:t>
+              <a:t>Split the data using a scaffold split using a ratio of  80%/20% train/test</a:t>
             </a:r>
           </a:p>
           <a:p>
-            <a:pPr lvl="1">
+            <a:pPr>
               <a:lnSpc>
                 <a:spcPct val="100000"/>
               </a:lnSpc>
@@ -12156,21 +13801,18 @@
               <a:buClr>
                 <a:srgbClr val="0064C8"/>
               </a:buClr>
-              <a:buFont typeface="Symbol" panose="05050102010706020507" pitchFamily="18" charset="2"/>
-              <a:buChar char="-"/>
+              <a:buFont typeface="Wingdings" panose="05000000000000000000" pitchFamily="2" charset="2"/>
+              <a:buChar char="§"/>
             </a:pPr>
-            <a:r>
-              <a:rPr lang="en-US" sz="1800" spc="-1" dirty="0">
-                <a:solidFill>
-                  <a:srgbClr val="000000"/>
-                </a:solidFill>
-                <a:latin typeface="Century Gothic"/>
-              </a:rPr>
-              <a:t>Dataset summary</a:t>
-            </a:r>
-          </a:p>
-          <a:p>
-            <a:pPr lvl="1">
+            <a:endParaRPr lang="en-US" sz="1400" spc="-1" dirty="0">
+              <a:solidFill>
+                <a:srgbClr val="000000"/>
+              </a:solidFill>
+              <a:latin typeface="Century Gothic"/>
+            </a:endParaRPr>
+          </a:p>
+          <a:p>
+            <a:pPr>
               <a:lnSpc>
                 <a:spcPct val="100000"/>
               </a:lnSpc>
@@ -12180,21 +13822,21 @@
               <a:buClr>
                 <a:srgbClr val="0064C8"/>
               </a:buClr>
-              <a:buFont typeface="Symbol" panose="05050102010706020507" pitchFamily="18" charset="2"/>
-              <a:buChar char="-"/>
+              <a:buFont typeface="Wingdings" panose="05000000000000000000" pitchFamily="2" charset="2"/>
+              <a:buChar char="§"/>
             </a:pPr>
             <a:r>
-              <a:rPr lang="en-US" sz="1800" spc="-1" dirty="0">
+              <a:rPr lang="en-US" sz="1400" spc="-1" dirty="0">
                 <a:solidFill>
                   <a:srgbClr val="000000"/>
                 </a:solidFill>
                 <a:latin typeface="Century Gothic"/>
               </a:rPr>
-              <a:t>Data split statistics</a:t>
+              <a:t>Train an RF model and perform a 5-fold CV for hyperparameter optimization</a:t>
             </a:r>
           </a:p>
           <a:p>
-            <a:pPr lvl="1">
+            <a:pPr>
               <a:lnSpc>
                 <a:spcPct val="100000"/>
               </a:lnSpc>
@@ -12204,21 +13846,18 @@
               <a:buClr>
                 <a:srgbClr val="0064C8"/>
               </a:buClr>
-              <a:buFont typeface="Symbol" panose="05050102010706020507" pitchFamily="18" charset="2"/>
-              <a:buChar char="-"/>
+              <a:buFont typeface="Wingdings" panose="05000000000000000000" pitchFamily="2" charset="2"/>
+              <a:buChar char="§"/>
             </a:pPr>
-            <a:r>
-              <a:rPr lang="en-US" sz="1800" spc="-1" dirty="0">
-                <a:solidFill>
-                  <a:srgbClr val="000000"/>
-                </a:solidFill>
-                <a:latin typeface="Century Gothic"/>
-              </a:rPr>
-              <a:t>Model training information</a:t>
-            </a:r>
-          </a:p>
-          <a:p>
-            <a:pPr lvl="1">
+            <a:endParaRPr lang="en-US" sz="1400" spc="-1" dirty="0">
+              <a:solidFill>
+                <a:srgbClr val="000000"/>
+              </a:solidFill>
+              <a:latin typeface="Century Gothic"/>
+            </a:endParaRPr>
+          </a:p>
+          <a:p>
+            <a:pPr>
               <a:lnSpc>
                 <a:spcPct val="100000"/>
               </a:lnSpc>
@@ -12228,18 +13867,45 @@
               <a:buClr>
                 <a:srgbClr val="0064C8"/>
               </a:buClr>
-              <a:buFont typeface="Symbol" panose="05050102010706020507" pitchFamily="18" charset="2"/>
-              <a:buChar char="-"/>
+              <a:buFont typeface="Wingdings" panose="05000000000000000000" pitchFamily="2" charset="2"/>
+              <a:buChar char="§"/>
             </a:pPr>
             <a:r>
-              <a:rPr lang="en-US" sz="1800" spc="-1" dirty="0">
+              <a:rPr lang="en-US" sz="1400" spc="-1" dirty="0">
                 <a:solidFill>
                   <a:srgbClr val="000000"/>
                 </a:solidFill>
                 <a:latin typeface="Century Gothic"/>
               </a:rPr>
-              <a:t>Test set performance </a:t>
+              <a:t>Calculate and display the test set performance using appropriate metrics</a:t>
             </a:r>
+            <a:endParaRPr lang="en-US" sz="1600" spc="-1" dirty="0">
+              <a:solidFill>
+                <a:srgbClr val="000000"/>
+              </a:solidFill>
+              <a:latin typeface="Century Gothic"/>
+            </a:endParaRPr>
+          </a:p>
+          <a:p>
+            <a:pPr>
+              <a:lnSpc>
+                <a:spcPct val="100000"/>
+              </a:lnSpc>
+              <a:spcBef>
+                <a:spcPts val="400"/>
+              </a:spcBef>
+              <a:buClr>
+                <a:srgbClr val="0064C8"/>
+              </a:buClr>
+              <a:buFont typeface="Wingdings" panose="05000000000000000000" pitchFamily="2" charset="2"/>
+              <a:buChar char="§"/>
+            </a:pPr>
+            <a:endParaRPr lang="en-US" sz="1800" spc="-1" dirty="0">
+              <a:solidFill>
+                <a:srgbClr val="000000"/>
+              </a:solidFill>
+              <a:latin typeface="Century Gothic"/>
+            </a:endParaRPr>
           </a:p>
           <a:p>
             <a:pPr marL="343080" indent="-343080">
@@ -12269,10 +13935,10 @@
       </p:sp>
       <p:pic>
         <p:nvPicPr>
-          <p:cNvPr id="6" name="Picture 5">
+          <p:cNvPr id="3" name="Picture 2">
             <a:extLst>
               <a:ext uri="{FF2B5EF4-FFF2-40B4-BE49-F238E27FC236}">
-                <a16:creationId xmlns:a16="http://schemas.microsoft.com/office/drawing/2014/main" id="{D3BA145D-265C-C0B1-7C0E-2EE32552E491}"/>
+                <a16:creationId xmlns:a16="http://schemas.microsoft.com/office/drawing/2014/main" id="{26877CA3-72FB-5BAD-B036-17D15BFC3DA0}"/>
               </a:ext>
             </a:extLst>
           </p:cNvPr>
@@ -12282,15 +13948,15 @@
           <p:nvPr/>
         </p:nvPicPr>
         <p:blipFill>
-          <a:blip r:embed="rId2"/>
+          <a:blip r:embed="rId3"/>
           <a:stretch>
             <a:fillRect/>
           </a:stretch>
         </p:blipFill>
         <p:spPr>
           <a:xfrm>
-            <a:off x="3817354" y="1196437"/>
-            <a:ext cx="4943606" cy="4598149"/>
+            <a:off x="4480608" y="1246234"/>
+            <a:ext cx="4140000" cy="4420744"/>
           </a:xfrm>
           <a:prstGeom prst="rect">
             <a:avLst/>
@@ -12300,7 +13966,7 @@
     </p:spTree>
     <p:extLst>
       <p:ext uri="{BB962C8B-B14F-4D97-AF65-F5344CB8AC3E}">
-        <p14:creationId xmlns:p14="http://schemas.microsoft.com/office/powerpoint/2010/main" val="2375808848"/>
+        <p14:creationId xmlns:p14="http://schemas.microsoft.com/office/powerpoint/2010/main" val="921095034"/>
       </p:ext>
     </p:extLst>
   </p:cSld>
@@ -16108,4 +17774,319 @@
   <a:objectDefaults/>
   <a:extraClrSchemeLst/>
 </a:theme>
+</file>
+
+<file path=ppt/theme/theme3.xml><?xml version="1.0" encoding="utf-8"?>
+<a:theme xmlns:a="http://schemas.openxmlformats.org/drawingml/2006/main" name="Office Theme">
+  <a:themeElements>
+    <a:clrScheme name="Office">
+      <a:dk1>
+        <a:sysClr val="windowText" lastClr="000000"/>
+      </a:dk1>
+      <a:lt1>
+        <a:sysClr val="window" lastClr="FFFFFF"/>
+      </a:lt1>
+      <a:dk2>
+        <a:srgbClr val="0E2841"/>
+      </a:dk2>
+      <a:lt2>
+        <a:srgbClr val="E8E8E8"/>
+      </a:lt2>
+      <a:accent1>
+        <a:srgbClr val="156082"/>
+      </a:accent1>
+      <a:accent2>
+        <a:srgbClr val="E97132"/>
+      </a:accent2>
+      <a:accent3>
+        <a:srgbClr val="196B24"/>
+      </a:accent3>
+      <a:accent4>
+        <a:srgbClr val="0F9ED5"/>
+      </a:accent4>
+      <a:accent5>
+        <a:srgbClr val="A02B93"/>
+      </a:accent5>
+      <a:accent6>
+        <a:srgbClr val="4EA72E"/>
+      </a:accent6>
+      <a:hlink>
+        <a:srgbClr val="467886"/>
+      </a:hlink>
+      <a:folHlink>
+        <a:srgbClr val="96607D"/>
+      </a:folHlink>
+    </a:clrScheme>
+    <a:fontScheme name="Office">
+      <a:majorFont>
+        <a:latin typeface="Aptos Display" panose="02110004020202020204"/>
+        <a:ea typeface=""/>
+        <a:cs typeface=""/>
+        <a:font script="Jpan" typeface="游ゴシック Light"/>
+        <a:font script="Hang" typeface="맑은 고딕"/>
+        <a:font script="Hans" typeface="等线 Light"/>
+        <a:font script="Hant" typeface="新細明體"/>
+        <a:font script="Arab" typeface="Times New Roman"/>
+        <a:font script="Hebr" typeface="Times New Roman"/>
+        <a:font script="Thai" typeface="Angsana New"/>
+        <a:font script="Ethi" typeface="Nyala"/>
+        <a:font script="Beng" typeface="Vrinda"/>
+        <a:font script="Gujr" typeface="Shruti"/>
+        <a:font script="Khmr" typeface="MoolBoran"/>
+        <a:font script="Knda" typeface="Tunga"/>
+        <a:font script="Guru" typeface="Raavi"/>
+        <a:font script="Cans" typeface="Euphemia"/>
+        <a:font script="Cher" typeface="Plantagenet Cherokee"/>
+        <a:font script="Yiii" typeface="Microsoft Yi Baiti"/>
+        <a:font script="Tibt" typeface="Microsoft Himalaya"/>
+        <a:font script="Thaa" typeface="MV Boli"/>
+        <a:font script="Deva" typeface="Mangal"/>
+        <a:font script="Telu" typeface="Gautami"/>
+        <a:font script="Taml" typeface="Latha"/>
+        <a:font script="Syrc" typeface="Estrangelo Edessa"/>
+        <a:font script="Orya" typeface="Kalinga"/>
+        <a:font script="Mlym" typeface="Kartika"/>
+        <a:font script="Laoo" typeface="DokChampa"/>
+        <a:font script="Sinh" typeface="Iskoola Pota"/>
+        <a:font script="Mong" typeface="Mongolian Baiti"/>
+        <a:font script="Viet" typeface="Times New Roman"/>
+        <a:font script="Uigh" typeface="Microsoft Uighur"/>
+        <a:font script="Geor" typeface="Sylfaen"/>
+        <a:font script="Armn" typeface="Arial"/>
+        <a:font script="Bugi" typeface="Leelawadee UI"/>
+        <a:font script="Bopo" typeface="Microsoft JhengHei"/>
+        <a:font script="Java" typeface="Javanese Text"/>
+        <a:font script="Lisu" typeface="Segoe UI"/>
+        <a:font script="Mymr" typeface="Myanmar Text"/>
+        <a:font script="Nkoo" typeface="Ebrima"/>
+        <a:font script="Olck" typeface="Nirmala UI"/>
+        <a:font script="Osma" typeface="Ebrima"/>
+        <a:font script="Phag" typeface="Phagspa"/>
+        <a:font script="Syrn" typeface="Estrangelo Edessa"/>
+        <a:font script="Syrj" typeface="Estrangelo Edessa"/>
+        <a:font script="Syre" typeface="Estrangelo Edessa"/>
+        <a:font script="Sora" typeface="Nirmala UI"/>
+        <a:font script="Tale" typeface="Microsoft Tai Le"/>
+        <a:font script="Talu" typeface="Microsoft New Tai Lue"/>
+        <a:font script="Tfng" typeface="Ebrima"/>
+      </a:majorFont>
+      <a:minorFont>
+        <a:latin typeface="Aptos" panose="02110004020202020204"/>
+        <a:ea typeface=""/>
+        <a:cs typeface=""/>
+        <a:font script="Jpan" typeface="游ゴシック"/>
+        <a:font script="Hang" typeface="맑은 고딕"/>
+        <a:font script="Hans" typeface="等线"/>
+        <a:font script="Hant" typeface="新細明體"/>
+        <a:font script="Arab" typeface="Arial"/>
+        <a:font script="Hebr" typeface="Arial"/>
+        <a:font script="Thai" typeface="Cordia New"/>
+        <a:font script="Ethi" typeface="Nyala"/>
+        <a:font script="Beng" typeface="Vrinda"/>
+        <a:font script="Gujr" typeface="Shruti"/>
+        <a:font script="Khmr" typeface="DaunPenh"/>
+        <a:font script="Knda" typeface="Tunga"/>
+        <a:font script="Guru" typeface="Raavi"/>
+        <a:font script="Cans" typeface="Euphemia"/>
+        <a:font script="Cher" typeface="Plantagenet Cherokee"/>
+        <a:font script="Yiii" typeface="Microsoft Yi Baiti"/>
+        <a:font script="Tibt" typeface="Microsoft Himalaya"/>
+        <a:font script="Thaa" typeface="MV Boli"/>
+        <a:font script="Deva" typeface="Mangal"/>
+        <a:font script="Telu" typeface="Gautami"/>
+        <a:font script="Taml" typeface="Latha"/>
+        <a:font script="Syrc" typeface="Estrangelo Edessa"/>
+        <a:font script="Orya" typeface="Kalinga"/>
+        <a:font script="Mlym" typeface="Kartika"/>
+        <a:font script="Laoo" typeface="DokChampa"/>
+        <a:font script="Sinh" typeface="Iskoola Pota"/>
+        <a:font script="Mong" typeface="Mongolian Baiti"/>
+        <a:font script="Viet" typeface="Arial"/>
+        <a:font script="Uigh" typeface="Microsoft Uighur"/>
+        <a:font script="Geor" typeface="Sylfaen"/>
+        <a:font script="Armn" typeface="Arial"/>
+        <a:font script="Bugi" typeface="Leelawadee UI"/>
+        <a:font script="Bopo" typeface="Microsoft JhengHei"/>
+        <a:font script="Java" typeface="Javanese Text"/>
+        <a:font script="Lisu" typeface="Segoe UI"/>
+        <a:font script="Mymr" typeface="Myanmar Text"/>
+        <a:font script="Nkoo" typeface="Ebrima"/>
+        <a:font script="Olck" typeface="Nirmala UI"/>
+        <a:font script="Osma" typeface="Ebrima"/>
+        <a:font script="Phag" typeface="Phagspa"/>
+        <a:font script="Syrn" typeface="Estrangelo Edessa"/>
+        <a:font script="Syrj" typeface="Estrangelo Edessa"/>
+        <a:font script="Syre" typeface="Estrangelo Edessa"/>
+        <a:font script="Sora" typeface="Nirmala UI"/>
+        <a:font script="Tale" typeface="Microsoft Tai Le"/>
+        <a:font script="Talu" typeface="Microsoft New Tai Lue"/>
+        <a:font script="Tfng" typeface="Ebrima"/>
+      </a:minorFont>
+    </a:fontScheme>
+    <a:fmtScheme name="Office">
+      <a:fillStyleLst>
+        <a:solidFill>
+          <a:schemeClr val="phClr"/>
+        </a:solidFill>
+        <a:gradFill rotWithShape="1">
+          <a:gsLst>
+            <a:gs pos="0">
+              <a:schemeClr val="phClr">
+                <a:lumMod val="110000"/>
+                <a:satMod val="105000"/>
+                <a:tint val="67000"/>
+              </a:schemeClr>
+            </a:gs>
+            <a:gs pos="50000">
+              <a:schemeClr val="phClr">
+                <a:lumMod val="105000"/>
+                <a:satMod val="103000"/>
+                <a:tint val="73000"/>
+              </a:schemeClr>
+            </a:gs>
+            <a:gs pos="100000">
+              <a:schemeClr val="phClr">
+                <a:lumMod val="105000"/>
+                <a:satMod val="109000"/>
+                <a:tint val="81000"/>
+              </a:schemeClr>
+            </a:gs>
+          </a:gsLst>
+          <a:lin ang="5400000" scaled="0"/>
+        </a:gradFill>
+        <a:gradFill rotWithShape="1">
+          <a:gsLst>
+            <a:gs pos="0">
+              <a:schemeClr val="phClr">
+                <a:satMod val="103000"/>
+                <a:lumMod val="102000"/>
+                <a:tint val="94000"/>
+              </a:schemeClr>
+            </a:gs>
+            <a:gs pos="50000">
+              <a:schemeClr val="phClr">
+                <a:satMod val="110000"/>
+                <a:lumMod val="100000"/>
+                <a:shade val="100000"/>
+              </a:schemeClr>
+            </a:gs>
+            <a:gs pos="100000">
+              <a:schemeClr val="phClr">
+                <a:lumMod val="99000"/>
+                <a:satMod val="120000"/>
+                <a:shade val="78000"/>
+              </a:schemeClr>
+            </a:gs>
+          </a:gsLst>
+          <a:lin ang="5400000" scaled="0"/>
+        </a:gradFill>
+      </a:fillStyleLst>
+      <a:lnStyleLst>
+        <a:ln w="12700" cap="flat" cmpd="sng" algn="ctr">
+          <a:solidFill>
+            <a:schemeClr val="phClr"/>
+          </a:solidFill>
+          <a:prstDash val="solid"/>
+          <a:miter lim="800000"/>
+        </a:ln>
+        <a:ln w="19050" cap="flat" cmpd="sng" algn="ctr">
+          <a:solidFill>
+            <a:schemeClr val="phClr"/>
+          </a:solidFill>
+          <a:prstDash val="solid"/>
+          <a:miter lim="800000"/>
+        </a:ln>
+        <a:ln w="25400" cap="flat" cmpd="sng" algn="ctr">
+          <a:solidFill>
+            <a:schemeClr val="phClr"/>
+          </a:solidFill>
+          <a:prstDash val="solid"/>
+          <a:miter lim="800000"/>
+        </a:ln>
+      </a:lnStyleLst>
+      <a:effectStyleLst>
+        <a:effectStyle>
+          <a:effectLst/>
+        </a:effectStyle>
+        <a:effectStyle>
+          <a:effectLst/>
+        </a:effectStyle>
+        <a:effectStyle>
+          <a:effectLst>
+            <a:outerShdw blurRad="57150" dist="19050" dir="5400000" algn="ctr" rotWithShape="0">
+              <a:srgbClr val="000000">
+                <a:alpha val="63000"/>
+              </a:srgbClr>
+            </a:outerShdw>
+          </a:effectLst>
+        </a:effectStyle>
+      </a:effectStyleLst>
+      <a:bgFillStyleLst>
+        <a:solidFill>
+          <a:schemeClr val="phClr"/>
+        </a:solidFill>
+        <a:solidFill>
+          <a:schemeClr val="phClr">
+            <a:tint val="95000"/>
+            <a:satMod val="170000"/>
+          </a:schemeClr>
+        </a:solidFill>
+        <a:gradFill rotWithShape="1">
+          <a:gsLst>
+            <a:gs pos="0">
+              <a:schemeClr val="phClr">
+                <a:tint val="93000"/>
+                <a:satMod val="150000"/>
+                <a:shade val="98000"/>
+                <a:lumMod val="102000"/>
+              </a:schemeClr>
+            </a:gs>
+            <a:gs pos="50000">
+              <a:schemeClr val="phClr">
+                <a:tint val="98000"/>
+                <a:satMod val="130000"/>
+                <a:shade val="90000"/>
+                <a:lumMod val="103000"/>
+              </a:schemeClr>
+            </a:gs>
+            <a:gs pos="100000">
+              <a:schemeClr val="phClr">
+                <a:shade val="63000"/>
+                <a:satMod val="120000"/>
+              </a:schemeClr>
+            </a:gs>
+          </a:gsLst>
+          <a:lin ang="5400000" scaled="0"/>
+        </a:gradFill>
+      </a:bgFillStyleLst>
+    </a:fmtScheme>
+  </a:themeElements>
+  <a:objectDefaults>
+    <a:lnDef>
+      <a:spPr/>
+      <a:bodyPr/>
+      <a:lstStyle/>
+      <a:style>
+        <a:lnRef idx="2">
+          <a:schemeClr val="accent1"/>
+        </a:lnRef>
+        <a:fillRef idx="0">
+          <a:schemeClr val="accent1"/>
+        </a:fillRef>
+        <a:effectRef idx="1">
+          <a:schemeClr val="accent1"/>
+        </a:effectRef>
+        <a:fontRef idx="minor">
+          <a:schemeClr val="tx1"/>
+        </a:fontRef>
+      </a:style>
+    </a:lnDef>
+  </a:objectDefaults>
+  <a:extraClrSchemeLst/>
+  <a:extLst>
+    <a:ext uri="{05A4C25C-085E-4340-85A3-A5531E510DB2}">
+      <thm15:themeFamily xmlns:thm15="http://schemas.microsoft.com/office/thememl/2012/main" name="Office Theme" id="{2E142A2C-CD16-42D6-873A-C26D2A0506FA}" vid="{1BDDFF52-6CD6-40A5-AB3C-68EB2F1E4D0A}"/>
+    </a:ext>
+  </a:extLst>
+</a:theme>
 </file>
</xml_diff>